<commit_message>
docs(slides): simplify OOP slides for a beginner audience
Each OOP slide now opens with a one-line plain-Thai definition and ends
with a "ผลที่ได้" box. Key code lines are highlighted. Polymorphism keeps
only home_url(), rule codes (BR-xx) and method names move to the notes,
and the Case class diagram is simplified with the full version kept as
backup slide B7.

Co-Authored-By: Claude Opus 5.5 <noreply@anthropic.com>
</commit_message>
<xml_diff>
--- a/docs/slides/LawFirm_Presentation.pptx
+++ b/docs/slides/LawFirm_Presentation.pptx
@@ -583,7 +583,7 @@
           <a:lstStyle/>
           <a:p>
             <a:r>
-              <a:t>Polymorphism คือเรียกเมธอดเดียว แต่ได้พฤติกรรมตามชนิดของ object มีสองตัวอย่าง ซ้าย home_url ทนายไปหน้าตารางวันนี้ ผู้จัดการไปหน้า dashboard ของผู้จัดการ แอดมินไปหน้าแอดมิน route /dashboard เรียกแค่ current_user.home_url() บรรทัดเดียว ไม่ต้องถามว่าเป็น role ไหน หน้าแรกสามแบบในสไลด์ 3 มาจากบรรทัดนี้ ขวา reminder_lead_days นัดศาลคืน 3 นัดพบลูกความคืน 1 กำหนดยื่นคืน 15 โค้ดที่ใช้งานเรียกบรรทัดเดียวเหมือนกันทุกชนิด ถ้าถูกถามว่ายังมี isinstance เหลือไหม มี 8 จุดใน api กับ factory ใน repository แต่เป็นการตรวจชนิดที่ขอบระบบ เช่น require_role ตรวจสิทธิ์ ส่วนพฤติกรรมตามบทบาทและชนิดนัดใช้ polymorphism ทั้งหมดครับ</a:t>
+              <a:t>Polymorphism คือเรียกเมธอดชื่อเดียว แต่ละคลาสตอบไม่เหมือนกัน ตัวอย่างคือ home_url ทนายไปหน้าตารางวันนี้ ผู้จัดการไปหน้า dashboard ของผู้จัดการ แอดมินไปหน้าแอดมิน route เรียกแค่ current_user.home_url() บรรทัดเดียว ไม่ต้องถามว่าเป็น role ไหน หน้าแรกสามแบบในสไลด์ 3 มาจากบรรทัดนี้ครับ ส่วน reminder_lead_days ของนัดสามชนิดก็เรียกบรรทัดเดียวเหมือนกันครับ</a:t>
             </a:r>
           </a:p>
         </p:txBody>
@@ -653,7 +653,7 @@
           <a:lstStyle/>
           <a:p>
             <a:r>
-              <a:t>Encapsulation สถานะของคดีกับสถานะการมอบหมายแก้ตรงจากข้างนอกไม่ได้ เก็บไว้ใน _status และเปิดให้อ่านผ่าน property status ที่ไม่มี setter ถ้าสั่ง case.status = ... จะได้ AttributeError การเปลี่ยนสถานะต้องผ่านเมธอดที่ตรวจกฎก่อน เช่น advance_status ต้องเลื่อนทีละขั้นตาม BR-7 และจะยื่นฟ้องได้ต้องมีทนายตอบรับแล้วตาม BR-18 ถ้าผิดกฎจะโยน error ภาพขวาคือหน้าคดีจริง คดีนี้อยู่ขั้นสืบพยาน ปุ่มจึงเสนอแค่ขั้นถัดไปคือตัดสิน เพราะ advance_status ไม่ยอมให้ข้ามขั้น ข้อยกเว้นมีที่เดียวคือ repository ตั้ง _status ตรงตอนโหลดแถวเดิมจากฐาน ค่านั้นผ่านกฎมาแล้วตอนบันทึก จึงไม่ต้องตรวจซ้ำครับ</a:t>
+              <a:t>Encapsulation สถานะของคดีกับสถานะการมอบหมายแก้ตรงจากข้างนอกไม่ได้ เก็บไว้ใน _status และเปิดให้อ่านผ่าน property status ที่ไม่มี setter ถ้าสั่ง case.status = ... จะได้ AttributeError การเปลี่ยนสถานะต้องผ่านเมธอดที่ตรวจกฎก่อน เช่น advance_status ต้องเลื่อนทีละขั้น และจะยื่นฟ้องได้ต้องมีทนายตอบรับแล้ว ถ้าผิดกฎจะโยน error ภาพขวาคือหน้าคดีจริง คดีนี้อยู่ขั้นสืบพยาน ปุ่มจึงเสนอแค่ขั้นถัดไปคือตัดสิน เพราะ advance_status ไม่ยอมให้ข้ามขั้น ข้อยกเว้นมีที่เดียวคือ repository ตั้ง _status ตรงตอนโหลดแถวเดิมจากฐาน ค่านั้นผ่านกฎมาแล้วตอนบันทึก จึงไม่ต้องตรวจซ้ำครับ</a:t>
             </a:r>
           </a:p>
         </p:txBody>
@@ -723,7 +723,7 @@
           <a:lstStyle/>
           <a:p>
             <a:r>
-              <a:t>Exception hierarchy error ทุกตัวในระบบเป็นคลาส มีแม่คือ DomainError และลูกสี่ตัวตามกลุ่มกฎ นัดชนตาม BR-1 เปลี่ยนสถานะผิดตาม BR-7 8 9 18 เลื่อนนัดไม่ได้ตาม BR-3 กับ 5 และการมอบหมายผิดกฎ BR-15 ถึง 19 ชั้น api จับ error ชนิดที่เจาะจงแล้วแปลเป็นภาษาคน เช่น นัดชนก็แสดงฟอร์มเดิมพร้อมข้อความ หรือการมอบหมายผิดก็ตอบ HTTP 409 ระบบนี้ไม่มี handler กลาง แต่ละ route จับ subclass ของตัวเอง และเทสต้อง assert ชนิด subclass ที่เจาะจงครับ</a:t>
+              <a:t>Exception hierarchy error ทุกตัวในระบบเป็นคลาส มีแม่คือ DomainError และลูกสี่ตัวตามกลุ่มกฎ นัดชนตาม BR-1 เปลี่ยนสถานะผิดตาม BR-7 8 9 18 เลื่อนนัดไม่ได้ตาม BR-3 กับ 5 และการมอบหมายผิดกฎ BR-15 ถึง 19 ชั้น api ไม่มี handler กลาง แต่ละ route จับ subclass ของตัวเองแล้วแปลเป็นภาษาคน เช่น นัดชนก็แสดงฟอร์มเดิมพร้อมข้อความ หรือมอบหมายผิดก็ตอบ HTTP 409 เทสต้อง assert ชนิด subclass ที่เจาะจงครับ</a:t>
             </a:r>
           </a:p>
         </p:txBody>
@@ -793,7 +793,7 @@
           <a:lstStyle/>
           <a:p>
             <a:r>
-              <a:t>flow ของคดีตั้งแต่เปิดจนปิด ขั้นหลักทั้งห้าขั้นมีเมธอดใน domain คุมกฎ ผู้จัดการเปิดคดี มอบหมายทนายด้วย assign_lawyer ทนายตอบรับหรือปฏิเสธด้วย accept หรือ decline จากนั้นเพิ่มนัดและเลื่อนสถานะคดี จนปิดคดีได้เมื่อ can_close เป็นจริง คือไม่มีนัดหรือกำหนดยื่นค้าง ทางแยกสีแดงคือการถอนตัว ทนายขอถอนตัว ผู้จัดการอนุมัติหรือไม่อนุมัติ ถ้าอนุมัติก็ย้ายหรือยกเลิกนัด ขั้นย้ายและยกเลิกนัดเป็นงานของ AppointmentRepository โดยตรง ไม่มีกฎใน domain คุมครับ</a:t>
+              <a:t>flow ของคดีตั้งแต่เปิดจนปิด ขั้นหลักทั้งห้าขั้นมีเมธอดใน domain คุมกฎ ผู้จัดการเปิดคดี มอบหมายทนายด้วย assign_lawyer ทนายตอบรับหรือปฏิเสธด้วย accept หรือ decline จากนั้นเพิ่มนัดและเลื่อนสถานะคดี จนปิดคดีได้เมื่อ can_close เป็นจริง คือไม่มีนัดหรือกำหนดยื่นค้าง ทางแยกสีแดงคือการถอนตัว ทนายขอถอนตัว ผู้จัดการอนุมัติหรือไม่อนุมัติ ถ้าอนุมัติก็ย้ายหรือยกเลิกนัด ขั้นย้ายและยกเลิกนัดเป็นงานของ AppointmentRepository โดยตรง ไม่มีกฎใน domain คุม ถ้าถามชื่อเมธอด ขั้นหลักคือ Case กับ repo.add assign_lawyer accept decline add advance_status can_close ส่วนทางแยกคือ request_withdraw approve reject_withdraw reassign cancel ครับ</a:t>
             </a:r>
           </a:p>
         </p:txBody>
@@ -1143,7 +1143,7 @@
           <a:lstStyle/>
           <a:p>
             <a:r>
-              <a:t>ฝั่งคดีและตาราง ตรงกลางคือ Case เก็บสถานะและรายการมอบหมายไว้เป็น private คดีหนึ่งมี CaseAssignment ได้หลายรายการ แต่ละรายการผูกกับทนายหนึ่งคน ซ้ายล่างคือ Appointment เป็นคลาส abstract มีลูกสามชนิด นัดศาล นัดพบลูกความ และกำหนดยื่นเอกสาร นัดศาลเตือนล่วงหน้า 3 วัน นัดพบลูกความ 1 วัน กำหนดยื่น 15 วัน ตัวเลขต่างกันแต่เรียกเมธอดเดียวกัน ขวามือคือ Schedule ไม่ได้สร้างนัดเอง แค่ยืมรายการนัดจาก repository มาตรวจนัดชน เป็นความสัมพันธ์แบบ aggregation และทุกคลาสใน domain เขียนเป็น dataclass ส่วนสถานะคดีกับสถานะการมอบหมายเป็น enum ครับ</a:t>
+              <a:t>ฝั่งคดีและตาราง ตรงกลางคือ Case เก็บสถานะและรายการมอบหมายไว้เป็น private คดีหนึ่งมี CaseAssignment ได้หลายรายการ ซ้ายล่าง Appointment เป็นคลาส abstract มีลูกสามชนิด ขวามือ Schedule ไม่ได้สร้างนัดเอง แค่ยืมรายการนัดจาก repository มาตรวจนัดชน ฉบับเต็มของแผนภาพนี้อยู่ในสไลด์สำรอง B7 ครับ</a:t>
             </a:r>
           </a:p>
         </p:txBody>
@@ -1283,7 +1283,7 @@
           <a:lstStyle/>
           <a:p>
             <a:r>
-              <a:t>Inheritance คลาสลูกได้ทุกอย่างจากแม่ แล้วเติมของตัวเอง Lawyer, Manager และ Admin ได้ username และ password จาก SystemUser แล้วแต่ละตัวเขียน display_name ของตัวเอง Lawyer เพิ่มเลขใบอนุญาตว่าความ ส่วน Client สืบจาก Person ตรงๆ จุดที่อาจารย์มักถามคือ ทำไม Client ไม่สืบจาก SystemUser คำตอบคือลูกความไม่มี username และ password จึงไม่ผ่านความสัมพันธ์แบบ is-a กับผู้ใช้ระบบครับ</a:t>
+              <a:t>Inheritance คลาสลูกได้ทุกอย่างจากแม่ แล้วเติมของตัวเอง Lawyer, Manager และ Admin ได้ username และ password จาก SystemUser แล้วแต่ละตัวเขียน display_name ของตัวเอง Lawyer ได้ทั้ง name phone จาก Person และ username password จาก SystemUser โดยไม่ต้องเขียนซ้ำ Lawyer เพิ่มแค่เลขใบอนุญาตว่าความ ส่วน Client สืบจาก Person ตรงๆ จุดที่อาจารย์มักถามคือ ทำไม Client ไม่สืบจาก SystemUser คำตอบคือลูกความไม่มี username และ password จึงไม่ผ่านความสัมพันธ์แบบ is-a กับผู้ใช้ระบบครับ</a:t>
             </a:r>
           </a:p>
         </p:txBody>
@@ -4896,7 +4896,7 @@
               </a:spcAft>
             </a:pPr>
             <a:r>
-              <a:rPr sz="1500" b="0">
+              <a:rPr sz="1400" b="0">
                 <a:solidFill>
                   <a:srgbClr val="FFFFFF"/>
                 </a:solidFill>
@@ -4904,7 +4904,7 @@
                 <a:ea typeface="Sarabun"/>
                 <a:cs typeface="Sarabun"/>
               </a:rPr>
-              <a:t>DomainError                (แม่)</a:t>
+              <a:t>DomainError (แม่)</a:t>
             </a:r>
           </a:p>
           <a:p>
@@ -4914,7 +4914,7 @@
               </a:spcAft>
             </a:pPr>
             <a:r>
-              <a:rPr sz="1500" b="0">
+              <a:rPr sz="1400" b="0">
                 <a:solidFill>
                   <a:srgbClr val="FFFFFF"/>
                 </a:solidFill>
@@ -4922,7 +4922,7 @@
                 <a:ea typeface="Sarabun"/>
                 <a:cs typeface="Sarabun"/>
               </a:rPr>
-              <a:t>├ ScheduleConflictError    BR-1</a:t>
+              <a:t>├ ScheduleConflictError  นัดเวลาชนกัน</a:t>
             </a:r>
           </a:p>
           <a:p>
@@ -4932,7 +4932,7 @@
               </a:spcAft>
             </a:pPr>
             <a:r>
-              <a:rPr sz="1500" b="0">
+              <a:rPr sz="1400" b="0">
                 <a:solidFill>
                   <a:srgbClr val="FFFFFF"/>
                 </a:solidFill>
@@ -4940,7 +4940,7 @@
                 <a:ea typeface="Sarabun"/>
                 <a:cs typeface="Sarabun"/>
               </a:rPr>
-              <a:t>├ InvalidStatusTransition  BR-7/8/9/18</a:t>
+              <a:t>├ InvalidStatusTransition  ข้ามขั้นสถานะ</a:t>
             </a:r>
           </a:p>
           <a:p>
@@ -4950,7 +4950,7 @@
               </a:spcAft>
             </a:pPr>
             <a:r>
-              <a:rPr sz="1500" b="0">
+              <a:rPr sz="1400" b="0">
                 <a:solidFill>
                   <a:srgbClr val="FFFFFF"/>
                 </a:solidFill>
@@ -4958,7 +4958,7 @@
                 <a:ea typeface="Sarabun"/>
                 <a:cs typeface="Sarabun"/>
               </a:rPr>
-              <a:t>├ RescheduleNotAllowed     BR-3/5</a:t>
+              <a:t>├ RescheduleNotAllowed  เลื่อนนัดไม่ได้</a:t>
             </a:r>
           </a:p>
           <a:p>
@@ -4968,7 +4968,7 @@
               </a:spcAft>
             </a:pPr>
             <a:r>
-              <a:rPr sz="1500" b="0">
+              <a:rPr sz="1400" b="0">
                 <a:solidFill>
                   <a:srgbClr val="FFFFFF"/>
                 </a:solidFill>
@@ -4976,7 +4976,7 @@
                 <a:ea typeface="Sarabun"/>
                 <a:cs typeface="Sarabun"/>
               </a:rPr>
-              <a:t>└ AssignmentError          BR-15…19</a:t>
+              <a:t>└ AssignmentError  มอบหมาย/รับคดีผิดกฎ</a:t>
             </a:r>
           </a:p>
         </p:txBody>
@@ -4990,7 +4990,7 @@
         <p:spPr>
           <a:xfrm>
             <a:off x="6223000" y="1587500"/>
-            <a:ext cx="5461000" cy="1143000"/>
+            <a:ext cx="5461000" cy="1219200"/>
           </a:xfrm>
           <a:prstGeom prst="rect">
             <a:avLst/>
@@ -5036,7 +5036,7 @@
         <p:spPr>
           <a:xfrm>
             <a:off x="6350000" y="1689100"/>
-            <a:ext cx="5207000" cy="939800"/>
+            <a:ext cx="5207000" cy="1016000"/>
           </a:xfrm>
           <a:prstGeom prst="rect">
             <a:avLst/>
@@ -5055,7 +5055,7 @@
               </a:spcAft>
             </a:pPr>
             <a:r>
-              <a:rPr sz="1400" b="0">
+              <a:rPr sz="1500" b="0">
                 <a:solidFill>
                   <a:srgbClr val="FFFFFF"/>
                 </a:solidFill>
@@ -5073,7 +5073,7 @@
               </a:spcAft>
             </a:pPr>
             <a:r>
-              <a:rPr sz="1400" b="0">
+              <a:rPr sz="1500" b="0">
                 <a:solidFill>
                   <a:srgbClr val="FFFFFF"/>
                 </a:solidFill>
@@ -5091,7 +5091,7 @@
               </a:spcAft>
             </a:pPr>
             <a:r>
-              <a:rPr sz="1400" b="0">
+              <a:rPr sz="1500" b="0">
                 <a:solidFill>
                   <a:srgbClr val="FFFFFF"/>
                 </a:solidFill>
@@ -5113,7 +5113,7 @@
         <p:spPr>
           <a:xfrm>
             <a:off x="6223000" y="2857500"/>
-            <a:ext cx="5461000" cy="1143000"/>
+            <a:ext cx="5461000" cy="1219200"/>
           </a:xfrm>
           <a:prstGeom prst="rect">
             <a:avLst/>
@@ -5159,7 +5159,7 @@
         <p:spPr>
           <a:xfrm>
             <a:off x="6350000" y="2959100"/>
-            <a:ext cx="5207000" cy="939800"/>
+            <a:ext cx="5207000" cy="1016000"/>
           </a:xfrm>
           <a:prstGeom prst="rect">
             <a:avLst/>
@@ -5178,7 +5178,7 @@
               </a:spcAft>
             </a:pPr>
             <a:r>
-              <a:rPr sz="1400" b="0">
+              <a:rPr sz="1500" b="0">
                 <a:solidFill>
                   <a:srgbClr val="FFFFFF"/>
                 </a:solidFill>
@@ -5196,7 +5196,7 @@
               </a:spcAft>
             </a:pPr>
             <a:r>
-              <a:rPr sz="1400" b="0">
+              <a:rPr sz="1500" b="0">
                 <a:solidFill>
                   <a:srgbClr val="FFFFFF"/>
                 </a:solidFill>
@@ -5211,14 +5211,58 @@
       </p:sp>
       <p:sp>
         <p:nvSpPr>
-          <p:cNvPr id="13" name="TextBox 12"/>
+          <p:cNvPr id="13" name="Rectangle 12"/>
+          <p:cNvSpPr/>
+          <p:nvPr/>
+        </p:nvSpPr>
+        <p:spPr>
+          <a:xfrm>
+            <a:off x="508000" y="5308600"/>
+            <a:ext cx="11176000" cy="558800"/>
+          </a:xfrm>
+          <a:prstGeom prst="rect">
+            <a:avLst/>
+          </a:prstGeom>
+          <a:solidFill>
+            <a:srgbClr val="362D4A"/>
+          </a:solidFill>
+          <a:ln>
+            <a:noFill/>
+          </a:ln>
+          <a:effectLst/>
+        </p:spPr>
+        <p:style>
+          <a:lnRef idx="1">
+            <a:schemeClr val="accent1"/>
+          </a:lnRef>
+          <a:fillRef idx="3">
+            <a:schemeClr val="accent1"/>
+          </a:fillRef>
+          <a:effectRef idx="2">
+            <a:schemeClr val="accent1"/>
+          </a:effectRef>
+          <a:fontRef idx="minor">
+            <a:schemeClr val="lt1"/>
+          </a:fontRef>
+        </p:style>
+        <p:txBody>
+          <a:bodyPr rtlCol="0" anchor="ctr"/>
+          <a:lstStyle/>
+          <a:p>
+            <a:pPr algn="ctr"/>
+          </a:p>
+        </p:txBody>
+      </p:sp>
+      <p:sp>
+        <p:nvSpPr>
+          <p:cNvPr id="14" name="TextBox 13"/>
           <p:cNvSpPr txBox="1"/>
           <p:nvPr/>
         </p:nvSpPr>
         <p:spPr>
           <a:xfrm>
-            <a:off x="508000" y="4254500"/>
-            <a:ext cx="11176000" cy="1270000"/>
+            <a:off x="635000" y="5359400"/>
+            <a:ext cx="10922000" cy="457200"/>
           </a:xfrm>
           <a:prstGeom prst="rect">
             <a:avLst/>
@@ -5226,18 +5270,18 @@
           <a:noFill/>
         </p:spPr>
         <p:txBody>
-          <a:bodyPr wrap="square" anchor="t" lIns="50800" rIns="50800" tIns="25400" bIns="25400">
+          <a:bodyPr wrap="square" anchor="ctr" lIns="50800" rIns="50800" tIns="25400" bIns="25400">
             <a:spAutoFit/>
           </a:bodyPr>
           <a:lstStyle/>
           <a:p>
-            <a:pPr algn="l">
-              <a:spcAft>
-                <a:spcPts val="800"/>
-              </a:spcAft>
-            </a:pPr>
-            <a:r>
-              <a:rPr sz="1600" b="0">
+            <a:pPr algn="ctr">
+              <a:spcAft>
+                <a:spcPts val="600"/>
+              </a:spcAft>
+            </a:pPr>
+            <a:r>
+              <a:rPr sz="1600" b="1">
                 <a:solidFill>
                   <a:srgbClr val="FFFFFF"/>
                 </a:solidFill>
@@ -5245,32 +5289,14 @@
                 <a:ea typeface="Sarabun"/>
                 <a:cs typeface="Sarabun"/>
               </a:rPr>
-              <a:t>• ไม่มี handler กลาง: แต่ละ route จับ subclass ของตัวเองแล้วแปลเป็นข้อความไทย</a:t>
-            </a:r>
-          </a:p>
-          <a:p>
-            <a:pPr algn="l">
-              <a:spcAft>
-                <a:spcPts val="800"/>
-              </a:spcAft>
-            </a:pPr>
-            <a:r>
-              <a:rPr sz="1600" b="0">
-                <a:solidFill>
-                  <a:srgbClr val="FFFFFF"/>
-                </a:solidFill>
-                <a:latin typeface="Sarabun"/>
-                <a:ea typeface="Sarabun"/>
-                <a:cs typeface="Sarabun"/>
-              </a:rPr>
-              <a:t>• เทสต้อง assert ชนิด subclass ที่เจาะจง</a:t>
-            </a:r>
-          </a:p>
-        </p:txBody>
-      </p:sp>
-      <p:sp>
-        <p:nvSpPr>
-          <p:cNvPr id="14" name="TextBox 13"/>
+              <a:t>ทำผิดกฎ → โยน error ชนิดเฉพาะ → หน้าเว็บแสดงข้อความไทย</a:t>
+            </a:r>
+          </a:p>
+        </p:txBody>
+      </p:sp>
+      <p:sp>
+        <p:nvSpPr>
+          <p:cNvPr id="15" name="TextBox 14"/>
           <p:cNvSpPr txBox="1"/>
           <p:nvPr/>
         </p:nvSpPr>
@@ -5620,7 +5646,7 @@
               </a:spcAft>
             </a:pPr>
             <a:r>
-              <a:rPr sz="1500" b="1">
+              <a:rPr sz="1600" b="1">
                 <a:solidFill>
                   <a:srgbClr val="FFFFFF"/>
                 </a:solidFill>
@@ -5629,24 +5655,6 @@
                 <a:cs typeface="Sarabun"/>
               </a:rPr>
               <a:t>เปิดคดี</a:t>
-            </a:r>
-          </a:p>
-          <a:p>
-            <a:pPr algn="ctr">
-              <a:spcAft>
-                <a:spcPts val="100"/>
-              </a:spcAft>
-            </a:pPr>
-            <a:r>
-              <a:rPr sz="1100" b="0">
-                <a:solidFill>
-                  <a:srgbClr val="A6A6A6"/>
-                </a:solidFill>
-                <a:latin typeface="Sarabun"/>
-                <a:ea typeface="Sarabun"/>
-                <a:cs typeface="Sarabun"/>
-              </a:rPr>
-              <a:t>Case() → repo.add()</a:t>
             </a:r>
           </a:p>
         </p:txBody>
@@ -5725,7 +5733,7 @@
               </a:spcAft>
             </a:pPr>
             <a:r>
-              <a:rPr sz="1500" b="1">
+              <a:rPr sz="1600" b="1">
                 <a:solidFill>
                   <a:srgbClr val="FFFFFF"/>
                 </a:solidFill>
@@ -5734,24 +5742,6 @@
                 <a:cs typeface="Sarabun"/>
               </a:rPr>
               <a:t>มอบหมายทนาย</a:t>
-            </a:r>
-          </a:p>
-          <a:p>
-            <a:pPr algn="ctr">
-              <a:spcAft>
-                <a:spcPts val="100"/>
-              </a:spcAft>
-            </a:pPr>
-            <a:r>
-              <a:rPr sz="1100" b="0">
-                <a:solidFill>
-                  <a:srgbClr val="A6A6A6"/>
-                </a:solidFill>
-                <a:latin typeface="Sarabun"/>
-                <a:ea typeface="Sarabun"/>
-                <a:cs typeface="Sarabun"/>
-              </a:rPr>
-              <a:t>case.assign_lawyer()</a:t>
             </a:r>
           </a:p>
         </p:txBody>
@@ -5866,7 +5856,7 @@
               </a:spcAft>
             </a:pPr>
             <a:r>
-              <a:rPr sz="1500" b="1">
+              <a:rPr sz="1600" b="1">
                 <a:solidFill>
                   <a:srgbClr val="FFFFFF"/>
                 </a:solidFill>
@@ -5875,24 +5865,6 @@
                 <a:cs typeface="Sarabun"/>
               </a:rPr>
               <a:t>รับ / ปฏิเสธ</a:t>
-            </a:r>
-          </a:p>
-          <a:p>
-            <a:pPr algn="ctr">
-              <a:spcAft>
-                <a:spcPts val="100"/>
-              </a:spcAft>
-            </a:pPr>
-            <a:r>
-              <a:rPr sz="1100" b="0">
-                <a:solidFill>
-                  <a:srgbClr val="A6A6A6"/>
-                </a:solidFill>
-                <a:latin typeface="Sarabun"/>
-                <a:ea typeface="Sarabun"/>
-                <a:cs typeface="Sarabun"/>
-              </a:rPr>
-              <a:t>accept() · decline()</a:t>
             </a:r>
           </a:p>
         </p:txBody>
@@ -6007,7 +5979,7 @@
               </a:spcAft>
             </a:pPr>
             <a:r>
-              <a:rPr sz="1500" b="1">
+              <a:rPr sz="1600" b="1">
                 <a:solidFill>
                   <a:srgbClr val="FFFFFF"/>
                 </a:solidFill>
@@ -6016,24 +5988,6 @@
                 <a:cs typeface="Sarabun"/>
               </a:rPr>
               <a:t>นัด + เลื่อนสถานะ</a:t>
-            </a:r>
-          </a:p>
-          <a:p>
-            <a:pPr algn="ctr">
-              <a:spcAft>
-                <a:spcPts val="100"/>
-              </a:spcAft>
-            </a:pPr>
-            <a:r>
-              <a:rPr sz="1100" b="0">
-                <a:solidFill>
-                  <a:srgbClr val="A6A6A6"/>
-                </a:solidFill>
-                <a:latin typeface="Sarabun"/>
-                <a:ea typeface="Sarabun"/>
-                <a:cs typeface="Sarabun"/>
-              </a:rPr>
-              <a:t>add() · advance_status()</a:t>
             </a:r>
           </a:p>
         </p:txBody>
@@ -6148,7 +6102,7 @@
               </a:spcAft>
             </a:pPr>
             <a:r>
-              <a:rPr sz="1500" b="1">
+              <a:rPr sz="1600" b="1">
                 <a:solidFill>
                   <a:srgbClr val="FFFFFF"/>
                 </a:solidFill>
@@ -6157,24 +6111,6 @@
                 <a:cs typeface="Sarabun"/>
               </a:rPr>
               <a:t>ปิดคดี</a:t>
-            </a:r>
-          </a:p>
-          <a:p>
-            <a:pPr algn="ctr">
-              <a:spcAft>
-                <a:spcPts val="100"/>
-              </a:spcAft>
-            </a:pPr>
-            <a:r>
-              <a:rPr sz="1100" b="0">
-                <a:solidFill>
-                  <a:srgbClr val="A6A6A6"/>
-                </a:solidFill>
-                <a:latin typeface="Sarabun"/>
-                <a:ea typeface="Sarabun"/>
-                <a:cs typeface="Sarabun"/>
-              </a:rPr>
-              <a:t>can_close() → CLOSED</a:t>
             </a:r>
           </a:p>
         </p:txBody>
@@ -6289,7 +6225,7 @@
               </a:spcAft>
             </a:pPr>
             <a:r>
-              <a:rPr sz="1500" b="1">
+              <a:rPr sz="1600" b="1">
                 <a:solidFill>
                   <a:srgbClr val="FFFFFF"/>
                 </a:solidFill>
@@ -6298,24 +6234,6 @@
                 <a:cs typeface="Sarabun"/>
               </a:rPr>
               <a:t>ขอถอนตัว</a:t>
-            </a:r>
-          </a:p>
-          <a:p>
-            <a:pPr algn="ctr">
-              <a:spcAft>
-                <a:spcPts val="100"/>
-              </a:spcAft>
-            </a:pPr>
-            <a:r>
-              <a:rPr sz="1100" b="0">
-                <a:solidFill>
-                  <a:srgbClr val="FF8A80"/>
-                </a:solidFill>
-                <a:latin typeface="Sarabun"/>
-                <a:ea typeface="Sarabun"/>
-                <a:cs typeface="Sarabun"/>
-              </a:rPr>
-              <a:t>request_withdraw()</a:t>
             </a:r>
           </a:p>
         </p:txBody>
@@ -6394,7 +6312,7 @@
               </a:spcAft>
             </a:pPr>
             <a:r>
-              <a:rPr sz="1500" b="1">
+              <a:rPr sz="1600" b="1">
                 <a:solidFill>
                   <a:srgbClr val="FFFFFF"/>
                 </a:solidFill>
@@ -6403,24 +6321,6 @@
                 <a:cs typeface="Sarabun"/>
               </a:rPr>
               <a:t>อนุมัติ / ไม่อนุมัติ</a:t>
-            </a:r>
-          </a:p>
-          <a:p>
-            <a:pPr algn="ctr">
-              <a:spcAft>
-                <a:spcPts val="100"/>
-              </a:spcAft>
-            </a:pPr>
-            <a:r>
-              <a:rPr sz="1100" b="0">
-                <a:solidFill>
-                  <a:srgbClr val="FF8A80"/>
-                </a:solidFill>
-                <a:latin typeface="Sarabun"/>
-                <a:ea typeface="Sarabun"/>
-                <a:cs typeface="Sarabun"/>
-              </a:rPr>
-              <a:t>approve/reject_withdraw()</a:t>
             </a:r>
           </a:p>
         </p:txBody>
@@ -6499,7 +6399,7 @@
               </a:spcAft>
             </a:pPr>
             <a:r>
-              <a:rPr sz="1500" b="1">
+              <a:rPr sz="1600" b="1">
                 <a:solidFill>
                   <a:srgbClr val="FFFFFF"/>
                 </a:solidFill>
@@ -6508,24 +6408,6 @@
                 <a:cs typeface="Sarabun"/>
               </a:rPr>
               <a:t>ย้าย / ยกเลิกนัด</a:t>
-            </a:r>
-          </a:p>
-          <a:p>
-            <a:pPr algn="ctr">
-              <a:spcAft>
-                <a:spcPts val="100"/>
-              </a:spcAft>
-            </a:pPr>
-            <a:r>
-              <a:rPr sz="1100" b="0">
-                <a:solidFill>
-                  <a:srgbClr val="FF8A80"/>
-                </a:solidFill>
-                <a:latin typeface="Sarabun"/>
-                <a:ea typeface="Sarabun"/>
-                <a:cs typeface="Sarabun"/>
-              </a:rPr>
-              <a:t>reassign() · cancel()</a:t>
             </a:r>
           </a:p>
         </p:txBody>
@@ -6647,8 +6529,8 @@
         </p:nvSpPr>
         <p:spPr>
           <a:xfrm>
-            <a:off x="7366000" y="4445000"/>
-            <a:ext cx="2032000" cy="279400"/>
+            <a:off x="9652000" y="3556000"/>
+            <a:ext cx="2032000" cy="635000"/>
           </a:xfrm>
           <a:prstGeom prst="rect">
             <a:avLst/>
@@ -6661,13 +6543,13 @@
           </a:bodyPr>
           <a:lstStyle/>
           <a:p>
-            <a:pPr algn="ctr">
+            <a:pPr algn="l">
               <a:spcAft>
                 <a:spcPts val="600"/>
               </a:spcAft>
             </a:pPr>
             <a:r>
-              <a:rPr sz="1100" b="0">
+              <a:rPr sz="1400" b="0">
                 <a:solidFill>
                   <a:srgbClr val="A6A6A6"/>
                 </a:solidFill>
@@ -6675,7 +6557,25 @@
                 <a:ea typeface="Sarabun"/>
                 <a:cs typeface="Sarabun"/>
               </a:rPr>
-              <a:t>ของ AppointmentRepository</a:t>
+              <a:t>กล่องแดง =</a:t>
+            </a:r>
+          </a:p>
+          <a:p>
+            <a:pPr algn="l">
+              <a:spcAft>
+                <a:spcPts val="600"/>
+              </a:spcAft>
+            </a:pPr>
+            <a:r>
+              <a:rPr sz="1400" b="0">
+                <a:solidFill>
+                  <a:srgbClr val="A6A6A6"/>
+                </a:solidFill>
+                <a:latin typeface="Sarabun"/>
+                <a:ea typeface="Sarabun"/>
+                <a:cs typeface="Sarabun"/>
+              </a:rPr>
+              <a:t>ทางแยกถอนตัว</a:t>
             </a:r>
           </a:p>
         </p:txBody>
@@ -6688,8 +6588,8 @@
         </p:nvSpPr>
         <p:spPr>
           <a:xfrm>
-            <a:off x="9652000" y="3556000"/>
-            <a:ext cx="2032000" cy="635000"/>
+            <a:off x="508000" y="5016500"/>
+            <a:ext cx="11176000" cy="762000"/>
           </a:xfrm>
           <a:prstGeom prst="rect">
             <a:avLst/>
@@ -6704,37 +6604,37 @@
           <a:p>
             <a:pPr algn="l">
               <a:spcAft>
-                <a:spcPts val="600"/>
-              </a:spcAft>
-            </a:pPr>
-            <a:r>
-              <a:rPr sz="1400" b="0">
-                <a:solidFill>
-                  <a:srgbClr val="A6A6A6"/>
+                <a:spcPts val="400"/>
+              </a:spcAft>
+            </a:pPr>
+            <a:r>
+              <a:rPr sz="1500" b="0">
+                <a:solidFill>
+                  <a:srgbClr val="FFFFFF"/>
                 </a:solidFill>
                 <a:latin typeface="Sarabun"/>
                 <a:ea typeface="Sarabun"/>
                 <a:cs typeface="Sarabun"/>
               </a:rPr>
-              <a:t>กล่องแดง =</a:t>
+              <a:t>• เส้นทึบ = ทางหลัก · เส้นประแดง = ทางแยกถอนตัว</a:t>
             </a:r>
           </a:p>
           <a:p>
             <a:pPr algn="l">
               <a:spcAft>
-                <a:spcPts val="600"/>
-              </a:spcAft>
-            </a:pPr>
-            <a:r>
-              <a:rPr sz="1400" b="0">
-                <a:solidFill>
-                  <a:srgbClr val="A6A6A6"/>
+                <a:spcPts val="400"/>
+              </a:spcAft>
+            </a:pPr>
+            <a:r>
+              <a:rPr sz="1500" b="0">
+                <a:solidFill>
+                  <a:srgbClr val="FFFFFF"/>
                 </a:solidFill>
                 <a:latin typeface="Sarabun"/>
                 <a:ea typeface="Sarabun"/>
                 <a:cs typeface="Sarabun"/>
               </a:rPr>
-              <a:t>ทางแยกถอนตัว</a:t>
+              <a:t>• ปิดคดีได้เมื่อไม่มีนัดในอนาคตหรือกำหนดยื่นค้าง</a:t>
             </a:r>
           </a:p>
         </p:txBody>
@@ -6742,65 +6642,6 @@
       <p:sp>
         <p:nvSpPr>
           <p:cNvPr id="32" name="TextBox 31"/>
-          <p:cNvSpPr txBox="1"/>
-          <p:nvPr/>
-        </p:nvSpPr>
-        <p:spPr>
-          <a:xfrm>
-            <a:off x="508000" y="5016500"/>
-            <a:ext cx="11176000" cy="762000"/>
-          </a:xfrm>
-          <a:prstGeom prst="rect">
-            <a:avLst/>
-          </a:prstGeom>
-          <a:noFill/>
-        </p:spPr>
-        <p:txBody>
-          <a:bodyPr wrap="square" anchor="t" lIns="50800" rIns="50800" tIns="25400" bIns="25400">
-            <a:spAutoFit/>
-          </a:bodyPr>
-          <a:lstStyle/>
-          <a:p>
-            <a:pPr algn="l">
-              <a:spcAft>
-                <a:spcPts val="400"/>
-              </a:spcAft>
-            </a:pPr>
-            <a:r>
-              <a:rPr sz="1500" b="0">
-                <a:solidFill>
-                  <a:srgbClr val="FFFFFF"/>
-                </a:solidFill>
-                <a:latin typeface="Sarabun"/>
-                <a:ea typeface="Sarabun"/>
-                <a:cs typeface="Sarabun"/>
-              </a:rPr>
-              <a:t>• เส้นทึบ = ทางหลัก · เส้นประแดง = ทางแยกถอนตัว</a:t>
-            </a:r>
-          </a:p>
-          <a:p>
-            <a:pPr algn="l">
-              <a:spcAft>
-                <a:spcPts val="400"/>
-              </a:spcAft>
-            </a:pPr>
-            <a:r>
-              <a:rPr sz="1500" b="0">
-                <a:solidFill>
-                  <a:srgbClr val="FFFFFF"/>
-                </a:solidFill>
-                <a:latin typeface="Sarabun"/>
-                <a:ea typeface="Sarabun"/>
-                <a:cs typeface="Sarabun"/>
-              </a:rPr>
-              <a:t>• ปิดคดีได้เมื่อไม่มีนัดในอนาคตหรือกำหนดยื่นค้าง (BR-9)</a:t>
-            </a:r>
-          </a:p>
-        </p:txBody>
-      </p:sp>
-      <p:sp>
-        <p:nvSpPr>
-          <p:cNvPr id="33" name="TextBox 32"/>
           <p:cNvSpPr txBox="1"/>
           <p:nvPr/>
         </p:nvSpPr>
@@ -10852,24 +10693,6 @@
               <a:t>accept() · decline()</a:t>
             </a:r>
           </a:p>
-          <a:p>
-            <a:pPr algn="ctr">
-              <a:spcAft>
-                <a:spcPts val="100"/>
-              </a:spcAft>
-            </a:pPr>
-            <a:r>
-              <a:rPr sz="1200" b="0">
-                <a:solidFill>
-                  <a:srgbClr val="FFFFFF"/>
-                </a:solidFill>
-                <a:latin typeface="Sarabun"/>
-                <a:ea typeface="Sarabun"/>
-                <a:cs typeface="Sarabun"/>
-              </a:rPr>
-              <a:t>request_withdraw() · approve/reject()</a:t>
-            </a:r>
-          </a:p>
         </p:txBody>
       </p:sp>
       <p:sp>
@@ -10975,24 +10798,6 @@
               <a:t>assign_lawyer() · advance_status()</a:t>
             </a:r>
           </a:p>
-          <a:p>
-            <a:pPr algn="ctr">
-              <a:spcAft>
-                <a:spcPts val="100"/>
-              </a:spcAft>
-            </a:pPr>
-            <a:r>
-              <a:rPr sz="1200" b="0">
-                <a:solidFill>
-                  <a:srgbClr val="FFFFFF"/>
-                </a:solidFill>
-                <a:latin typeface="Sarabun"/>
-                <a:ea typeface="Sarabun"/>
-                <a:cs typeface="Sarabun"/>
-              </a:rPr>
-              <a:t>lawyers() · lead_lawyer() · can_close()</a:t>
-            </a:r>
-          </a:p>
         </p:txBody>
       </p:sp>
       <p:sp>
@@ -11098,24 +10903,6 @@
               <a:t>add() · find_conflicts()</a:t>
             </a:r>
           </a:p>
-          <a:p>
-            <a:pPr algn="ctr">
-              <a:spcAft>
-                <a:spcPts val="100"/>
-              </a:spcAft>
-            </a:pPr>
-            <a:r>
-              <a:rPr sz="1200" b="0">
-                <a:solidFill>
-                  <a:srgbClr val="FFFFFF"/>
-                </a:solidFill>
-                <a:latin typeface="Sarabun"/>
-                <a:ea typeface="Sarabun"/>
-                <a:cs typeface="Sarabun"/>
-              </a:rPr>
-              <a:t>day/week/month_view() · mark_done()</a:t>
-            </a:r>
-          </a:p>
         </p:txBody>
       </p:sp>
       <p:cxnSp>
@@ -11454,42 +11241,6 @@
                 <a:cs typeface="Sarabun"/>
               </a:rPr>
               <a:t>reminder_lead_days()* · kind_label()*</a:t>
-            </a:r>
-          </a:p>
-          <a:p>
-            <a:pPr algn="ctr">
-              <a:spcAft>
-                <a:spcPts val="100"/>
-              </a:spcAft>
-            </a:pPr>
-            <a:r>
-              <a:rPr sz="1200" b="0">
-                <a:solidFill>
-                  <a:srgbClr val="FFFFFF"/>
-                </a:solidFill>
-                <a:latin typeface="Sarabun"/>
-                <a:ea typeface="Sarabun"/>
-                <a:cs typeface="Sarabun"/>
-              </a:rPr>
-              <a:t>can_reschedule()* · overlaps()</a:t>
-            </a:r>
-          </a:p>
-          <a:p>
-            <a:pPr algn="ctr">
-              <a:spcAft>
-                <a:spcPts val="100"/>
-              </a:spcAft>
-            </a:pPr>
-            <a:r>
-              <a:rPr sz="1200" b="0">
-                <a:solidFill>
-                  <a:srgbClr val="FFFFFF"/>
-                </a:solidFill>
-                <a:latin typeface="Sarabun"/>
-                <a:ea typeface="Sarabun"/>
-                <a:cs typeface="Sarabun"/>
-              </a:rPr>
-              <a:t>reschedule() · cancel() · is_due_soon()</a:t>
             </a:r>
           </a:p>
         </p:txBody>
@@ -11873,24 +11624,6 @@
               <a:t>คดี 1 : * (ผูกด้วย case_id)</a:t>
             </a:r>
           </a:p>
-          <a:p>
-            <a:pPr algn="ctr">
-              <a:spcAft>
-                <a:spcPts val="100"/>
-              </a:spcAft>
-            </a:pPr>
-            <a:r>
-              <a:rPr sz="1200" b="0">
-                <a:solidFill>
-                  <a:srgbClr val="A6A6A6"/>
-                </a:solidFill>
-                <a:latin typeface="Sarabun"/>
-                <a:ea typeface="Sarabun"/>
-                <a:cs typeface="Sarabun"/>
-              </a:rPr>
-              <a:t>validate_text() · can_modify()</a:t>
-            </a:r>
-          </a:p>
         </p:txBody>
       </p:sp>
       <p:sp>
@@ -12117,24 +11850,6 @@
                 <a:cs typeface="Sarabun"/>
               </a:rPr>
               <a:t>AssignmentStatus 4 ค่า</a:t>
-            </a:r>
-          </a:p>
-          <a:p>
-            <a:pPr algn="ctr">
-              <a:spcAft>
-                <a:spcPts val="100"/>
-              </a:spcAft>
-            </a:pPr>
-            <a:r>
-              <a:rPr sz="1200" b="0">
-                <a:solidFill>
-                  <a:srgbClr val="A6A6A6"/>
-                </a:solidFill>
-                <a:latin typeface="Sarabun"/>
-                <a:ea typeface="Sarabun"/>
-                <a:cs typeface="Sarabun"/>
-              </a:rPr>
-              <a:t>domain ทุกคลาสเป็น @dataclass</a:t>
             </a:r>
           </a:p>
         </p:txBody>
@@ -12478,14 +12193,55 @@
       </p:sp>
       <p:sp>
         <p:nvSpPr>
-          <p:cNvPr id="7" name="Rectangle 6"/>
+          <p:cNvPr id="7" name="TextBox 6"/>
+          <p:cNvSpPr txBox="1"/>
+          <p:nvPr/>
+        </p:nvSpPr>
+        <p:spPr>
+          <a:xfrm>
+            <a:off x="508000" y="1371600"/>
+            <a:ext cx="11176000" cy="381000"/>
+          </a:xfrm>
+          <a:prstGeom prst="rect">
+            <a:avLst/>
+          </a:prstGeom>
+          <a:noFill/>
+        </p:spPr>
+        <p:txBody>
+          <a:bodyPr wrap="square" anchor="t" lIns="50800" rIns="50800" tIns="25400" bIns="25400">
+            <a:spAutoFit/>
+          </a:bodyPr>
+          <a:lstStyle/>
+          <a:p>
+            <a:pPr algn="l">
+              <a:spcAft>
+                <a:spcPts val="600"/>
+              </a:spcAft>
+            </a:pPr>
+            <a:r>
+              <a:rPr sz="1800" b="1">
+                <a:solidFill>
+                  <a:srgbClr val="B39DDB"/>
+                </a:solidFill>
+                <a:latin typeface="Sarabun"/>
+                <a:ea typeface="Sarabun"/>
+                <a:cs typeface="Sarabun"/>
+              </a:rPr>
+              <a:t>คลาสแม่บอกว่าลูกต้องมีเมธอดอะไร แต่ไม่บอกว่าทำยังไง</a:t>
+            </a:r>
+          </a:p>
+        </p:txBody>
+      </p:sp>
+      <p:sp>
+        <p:nvSpPr>
+          <p:cNvPr id="8" name="Rectangle 7"/>
           <p:cNvSpPr/>
           <p:nvPr/>
         </p:nvSpPr>
         <p:spPr>
           <a:xfrm>
-            <a:off x="508000" y="1524000"/>
-            <a:ext cx="5461000" cy="2667000"/>
+            <a:off x="508000" y="1803400"/>
+            <a:ext cx="5461000" cy="2349500"/>
           </a:xfrm>
           <a:prstGeom prst="rect">
             <a:avLst/>
@@ -12524,14 +12280,14 @@
       </p:sp>
       <p:sp>
         <p:nvSpPr>
-          <p:cNvPr id="8" name="TextBox 7"/>
+          <p:cNvPr id="9" name="TextBox 8"/>
           <p:cNvSpPr txBox="1"/>
           <p:nvPr/>
         </p:nvSpPr>
         <p:spPr>
           <a:xfrm>
-            <a:off x="635000" y="1625600"/>
-            <a:ext cx="5207000" cy="2463800"/>
+            <a:off x="635000" y="1905000"/>
+            <a:ext cx="5207000" cy="2146300"/>
           </a:xfrm>
           <a:prstGeom prst="rect">
             <a:avLst/>
@@ -12604,6 +12360,24 @@
               </a:spcAft>
             </a:pPr>
             <a:r>
+              <a:rPr sz="1400" b="1">
+                <a:solidFill>
+                  <a:srgbClr val="B39DDB"/>
+                </a:solidFill>
+                <a:latin typeface="Menlo"/>
+                <a:ea typeface="Sarabun"/>
+                <a:cs typeface="Sarabun"/>
+              </a:rPr>
+              <a:t>    def display_name(self): ...</a:t>
+            </a:r>
+          </a:p>
+          <a:p>
+            <a:pPr algn="l">
+              <a:spcAft>
+                <a:spcPts val="200"/>
+              </a:spcAft>
+            </a:pPr>
+            <a:r>
               <a:rPr sz="1400" b="0">
                 <a:solidFill>
                   <a:srgbClr val="FFFFFF"/>
@@ -12612,7 +12386,7 @@
                 <a:ea typeface="Sarabun"/>
                 <a:cs typeface="Sarabun"/>
               </a:rPr>
-              <a:t>    def display_name(self): ...</a:t>
+              <a:t/>
             </a:r>
           </a:p>
           <a:p>
@@ -12630,7 +12404,7 @@
                 <a:ea typeface="Sarabun"/>
                 <a:cs typeface="Sarabun"/>
               </a:rPr>
-              <a:t/>
+              <a:t>class SystemUser(Person):</a:t>
             </a:r>
           </a:p>
           <a:p>
@@ -12648,7 +12422,7 @@
                 <a:ea typeface="Sarabun"/>
                 <a:cs typeface="Sarabun"/>
               </a:rPr>
-              <a:t>class SystemUser(Person):</a:t>
+              <a:t>    @abstractmethod can_view_case()</a:t>
             </a:r>
           </a:p>
           <a:p>
@@ -12666,7 +12440,7 @@
                 <a:ea typeface="Sarabun"/>
                 <a:cs typeface="Sarabun"/>
               </a:rPr>
-              <a:t>    @abstractmethod can_view_case()</a:t>
+              <a:t>    @abstractmethod dashboard_cards()</a:t>
             </a:r>
           </a:p>
           <a:p>
@@ -12684,24 +12458,6 @@
                 <a:ea typeface="Sarabun"/>
                 <a:cs typeface="Sarabun"/>
               </a:rPr>
-              <a:t>    @abstractmethod dashboard_cards()</a:t>
-            </a:r>
-          </a:p>
-          <a:p>
-            <a:pPr algn="l">
-              <a:spcAft>
-                <a:spcPts val="200"/>
-              </a:spcAft>
-            </a:pPr>
-            <a:r>
-              <a:rPr sz="1400" b="0">
-                <a:solidFill>
-                  <a:srgbClr val="FFFFFF"/>
-                </a:solidFill>
-                <a:latin typeface="Menlo"/>
-                <a:ea typeface="Sarabun"/>
-                <a:cs typeface="Sarabun"/>
-              </a:rPr>
               <a:t>    @abstractmethod home_url()</a:t>
             </a:r>
           </a:p>
@@ -12709,14 +12465,14 @@
       </p:sp>
       <p:sp>
         <p:nvSpPr>
-          <p:cNvPr id="9" name="Rectangle 8"/>
+          <p:cNvPr id="10" name="Rectangle 9"/>
           <p:cNvSpPr/>
           <p:nvPr/>
         </p:nvSpPr>
         <p:spPr>
           <a:xfrm>
-            <a:off x="6223000" y="1524000"/>
-            <a:ext cx="5461000" cy="2667000"/>
+            <a:off x="6223000" y="1803400"/>
+            <a:ext cx="5461000" cy="2349500"/>
           </a:xfrm>
           <a:prstGeom prst="rect">
             <a:avLst/>
@@ -12755,14 +12511,14 @@
       </p:sp>
       <p:sp>
         <p:nvSpPr>
-          <p:cNvPr id="10" name="TextBox 9"/>
+          <p:cNvPr id="11" name="TextBox 10"/>
           <p:cNvSpPr txBox="1"/>
           <p:nvPr/>
         </p:nvSpPr>
         <p:spPr>
           <a:xfrm>
-            <a:off x="6350000" y="1625600"/>
-            <a:ext cx="5207000" cy="2463800"/>
+            <a:off x="6350000" y="1905000"/>
+            <a:ext cx="5207000" cy="2146300"/>
           </a:xfrm>
           <a:prstGeom prst="rect">
             <a:avLst/>
@@ -12835,6 +12591,24 @@
               </a:spcAft>
             </a:pPr>
             <a:r>
+              <a:rPr sz="1400" b="1">
+                <a:solidFill>
+                  <a:srgbClr val="B39DDB"/>
+                </a:solidFill>
+                <a:latin typeface="Menlo"/>
+                <a:ea typeface="Sarabun"/>
+                <a:cs typeface="Sarabun"/>
+              </a:rPr>
+              <a:t>    def reminder_lead_days(self): ...</a:t>
+            </a:r>
+          </a:p>
+          <a:p>
+            <a:pPr algn="l">
+              <a:spcAft>
+                <a:spcPts val="200"/>
+              </a:spcAft>
+            </a:pPr>
+            <a:r>
               <a:rPr sz="1400" b="0">
                 <a:solidFill>
                   <a:srgbClr val="FFFFFF"/>
@@ -12843,7 +12617,7 @@
                 <a:ea typeface="Sarabun"/>
                 <a:cs typeface="Sarabun"/>
               </a:rPr>
-              <a:t>    def reminder_lead_days(self): ...</a:t>
+              <a:t>    @abstractmethod</a:t>
             </a:r>
           </a:p>
           <a:p>
@@ -12861,6 +12635,24 @@
                 <a:ea typeface="Sarabun"/>
                 <a:cs typeface="Sarabun"/>
               </a:rPr>
+              <a:t>    def can_reschedule(self): ...</a:t>
+            </a:r>
+          </a:p>
+          <a:p>
+            <a:pPr algn="l">
+              <a:spcAft>
+                <a:spcPts val="200"/>
+              </a:spcAft>
+            </a:pPr>
+            <a:r>
+              <a:rPr sz="1400" b="0">
+                <a:solidFill>
+                  <a:srgbClr val="FFFFFF"/>
+                </a:solidFill>
+                <a:latin typeface="Menlo"/>
+                <a:ea typeface="Sarabun"/>
+                <a:cs typeface="Sarabun"/>
+              </a:rPr>
               <a:t>    @abstractmethod</a:t>
             </a:r>
           </a:p>
@@ -12879,42 +12671,6 @@
                 <a:ea typeface="Sarabun"/>
                 <a:cs typeface="Sarabun"/>
               </a:rPr>
-              <a:t>    def can_reschedule(self): ...</a:t>
-            </a:r>
-          </a:p>
-          <a:p>
-            <a:pPr algn="l">
-              <a:spcAft>
-                <a:spcPts val="200"/>
-              </a:spcAft>
-            </a:pPr>
-            <a:r>
-              <a:rPr sz="1400" b="0">
-                <a:solidFill>
-                  <a:srgbClr val="FFFFFF"/>
-                </a:solidFill>
-                <a:latin typeface="Menlo"/>
-                <a:ea typeface="Sarabun"/>
-                <a:cs typeface="Sarabun"/>
-              </a:rPr>
-              <a:t>    @abstractmethod</a:t>
-            </a:r>
-          </a:p>
-          <a:p>
-            <a:pPr algn="l">
-              <a:spcAft>
-                <a:spcPts val="200"/>
-              </a:spcAft>
-            </a:pPr>
-            <a:r>
-              <a:rPr sz="1400" b="0">
-                <a:solidFill>
-                  <a:srgbClr val="FFFFFF"/>
-                </a:solidFill>
-                <a:latin typeface="Menlo"/>
-                <a:ea typeface="Sarabun"/>
-                <a:cs typeface="Sarabun"/>
-              </a:rPr>
               <a:t>    def kind_label(self): ...</a:t>
             </a:r>
           </a:p>
@@ -12922,7 +12678,7 @@
       </p:sp>
       <p:sp>
         <p:nvSpPr>
-          <p:cNvPr id="11" name="Rectangle 10"/>
+          <p:cNvPr id="12" name="Rectangle 11"/>
           <p:cNvSpPr/>
           <p:nvPr/>
         </p:nvSpPr>
@@ -12968,7 +12724,7 @@
       </p:sp>
       <p:sp>
         <p:nvSpPr>
-          <p:cNvPr id="12" name="TextBox 11"/>
+          <p:cNvPr id="13" name="TextBox 12"/>
           <p:cNvSpPr txBox="1"/>
           <p:nvPr/>
         </p:nvSpPr>
@@ -13027,14 +12783,14 @@
       </p:sp>
       <p:sp>
         <p:nvSpPr>
-          <p:cNvPr id="13" name="TextBox 12"/>
+          <p:cNvPr id="14" name="TextBox 13"/>
           <p:cNvSpPr txBox="1"/>
           <p:nvPr/>
         </p:nvSpPr>
         <p:spPr>
           <a:xfrm>
-            <a:off x="508000" y="4381500"/>
-            <a:ext cx="5461000" cy="1397000"/>
+            <a:off x="508000" y="4254500"/>
+            <a:ext cx="5461000" cy="889000"/>
           </a:xfrm>
           <a:prstGeom prst="rect">
             <a:avLst/>
@@ -13061,17 +12817,84 @@
                 <a:ea typeface="Sarabun"/>
                 <a:cs typeface="Sarabun"/>
               </a:rPr>
-              <a:t>• สร้างได้เฉพาะคลาสลูก</a:t>
-            </a:r>
-          </a:p>
-          <a:p>
-            <a:pPr algn="l">
-              <a:spcAft>
-                <a:spcPts val="800"/>
-              </a:spcAft>
-            </a:pPr>
-            <a:r>
-              <a:rPr sz="1600" b="0">
+              <a:t>• contact_info()/overlaps() เขียนที่แม่ครั้งเดียว ลูกทุกตัวใช้ร่วมกัน</a:t>
+            </a:r>
+          </a:p>
+        </p:txBody>
+      </p:sp>
+      <p:sp>
+        <p:nvSpPr>
+          <p:cNvPr id="15" name="Rectangle 14"/>
+          <p:cNvSpPr/>
+          <p:nvPr/>
+        </p:nvSpPr>
+        <p:spPr>
+          <a:xfrm>
+            <a:off x="508000" y="5232400"/>
+            <a:ext cx="11176000" cy="508000"/>
+          </a:xfrm>
+          <a:prstGeom prst="rect">
+            <a:avLst/>
+          </a:prstGeom>
+          <a:solidFill>
+            <a:srgbClr val="362D4A"/>
+          </a:solidFill>
+          <a:ln>
+            <a:noFill/>
+          </a:ln>
+          <a:effectLst/>
+        </p:spPr>
+        <p:style>
+          <a:lnRef idx="1">
+            <a:schemeClr val="accent1"/>
+          </a:lnRef>
+          <a:fillRef idx="3">
+            <a:schemeClr val="accent1"/>
+          </a:fillRef>
+          <a:effectRef idx="2">
+            <a:schemeClr val="accent1"/>
+          </a:effectRef>
+          <a:fontRef idx="minor">
+            <a:schemeClr val="lt1"/>
+          </a:fontRef>
+        </p:style>
+        <p:txBody>
+          <a:bodyPr rtlCol="0" anchor="ctr"/>
+          <a:lstStyle/>
+          <a:p>
+            <a:pPr algn="ctr"/>
+          </a:p>
+        </p:txBody>
+      </p:sp>
+      <p:sp>
+        <p:nvSpPr>
+          <p:cNvPr id="16" name="TextBox 15"/>
+          <p:cNvSpPr txBox="1"/>
+          <p:nvPr/>
+        </p:nvSpPr>
+        <p:spPr>
+          <a:xfrm>
+            <a:off x="635000" y="5283200"/>
+            <a:ext cx="10922000" cy="406400"/>
+          </a:xfrm>
+          <a:prstGeom prst="rect">
+            <a:avLst/>
+          </a:prstGeom>
+          <a:noFill/>
+        </p:spPr>
+        <p:txBody>
+          <a:bodyPr wrap="square" anchor="ctr" lIns="50800" rIns="50800" tIns="25400" bIns="25400">
+            <a:spAutoFit/>
+          </a:bodyPr>
+          <a:lstStyle/>
+          <a:p>
+            <a:pPr algn="ctr">
+              <a:spcAft>
+                <a:spcPts val="600"/>
+              </a:spcAft>
+            </a:pPr>
+            <a:r>
+              <a:rPr sz="1600" b="1">
                 <a:solidFill>
                   <a:srgbClr val="FFFFFF"/>
                 </a:solidFill>
@@ -13079,14 +12902,14 @@
                 <a:ea typeface="Sarabun"/>
                 <a:cs typeface="Sarabun"/>
               </a:rPr>
-              <a:t>• contact_info() / overlaps() เขียนที่แม่ครั้งเดียว ลูกทุกตัวใช้ร่วมกัน</a:t>
-            </a:r>
-          </a:p>
-        </p:txBody>
-      </p:sp>
-      <p:sp>
-        <p:nvSpPr>
-          <p:cNvPr id="14" name="TextBox 13"/>
+              <a:t>ผลที่ได้: สร้าง Appointment() ตรงๆ ไม่ได้ ต้องสร้างคลาสลูก</a:t>
+            </a:r>
+          </a:p>
+        </p:txBody>
+      </p:sp>
+      <p:sp>
+        <p:nvSpPr>
+          <p:cNvPr id="17" name="TextBox 16"/>
           <p:cNvSpPr txBox="1"/>
           <p:nvPr/>
         </p:nvSpPr>
@@ -13362,17 +13185,58 @@
           </a:p>
         </p:txBody>
       </p:sp>
+      <p:sp>
+        <p:nvSpPr>
+          <p:cNvPr id="7" name="TextBox 6"/>
+          <p:cNvSpPr txBox="1"/>
+          <p:nvPr/>
+        </p:nvSpPr>
+        <p:spPr>
+          <a:xfrm>
+            <a:off x="508000" y="1371600"/>
+            <a:ext cx="11176000" cy="381000"/>
+          </a:xfrm>
+          <a:prstGeom prst="rect">
+            <a:avLst/>
+          </a:prstGeom>
+          <a:noFill/>
+        </p:spPr>
+        <p:txBody>
+          <a:bodyPr wrap="square" anchor="t" lIns="50800" rIns="50800" tIns="25400" bIns="25400">
+            <a:spAutoFit/>
+          </a:bodyPr>
+          <a:lstStyle/>
+          <a:p>
+            <a:pPr algn="l">
+              <a:spcAft>
+                <a:spcPts val="600"/>
+              </a:spcAft>
+            </a:pPr>
+            <a:r>
+              <a:rPr sz="1800" b="1">
+                <a:solidFill>
+                  <a:srgbClr val="B39DDB"/>
+                </a:solidFill>
+                <a:latin typeface="Sarabun"/>
+                <a:ea typeface="Sarabun"/>
+                <a:cs typeface="Sarabun"/>
+              </a:rPr>
+              <a:t>ลูกได้ทุกอย่างจากแม่ แล้วเติมของตัวเอง</a:t>
+            </a:r>
+          </a:p>
+        </p:txBody>
+      </p:sp>
       <p:graphicFrame>
         <p:nvGraphicFramePr>
-          <p:cNvPr id="7" name="Table 6"/>
+          <p:cNvPr id="8" name="Table 7"/>
           <p:cNvGraphicFramePr>
             <a:graphicFrameLocks noGrp="1"/>
           </p:cNvGraphicFramePr>
           <p:nvPr/>
         </p:nvGraphicFramePr>
         <p:xfrm>
-          <a:off x="508000" y="1587500"/>
-          <a:ext cx="11176000" cy="3556000"/>
+          <a:off x="508000" y="1879600"/>
+          <a:ext cx="11176000" cy="2844800"/>
         </p:xfrm>
         <a:graphic>
           <a:graphicData uri="http://schemas.openxmlformats.org/drawingml/2006/table">
@@ -13384,7 +13248,7 @@
                 <a:gridCol w="3175000"/>
                 <a:gridCol w="8001000"/>
               </a:tblGrid>
-              <a:tr h="508000">
+              <a:tr h="406400">
                 <a:tc>
                   <a:txBody>
                     <a:bodyPr/>
@@ -13434,7 +13298,7 @@
                   </a:tcPr>
                 </a:tc>
               </a:tr>
-              <a:tr h="508000">
+              <a:tr h="406400">
                 <a:tc>
                   <a:txBody>
                     <a:bodyPr/>
@@ -13484,7 +13348,7 @@
                   </a:tcPr>
                 </a:tc>
               </a:tr>
-              <a:tr h="508000">
+              <a:tr h="406400">
                 <a:tc>
                   <a:txBody>
                     <a:bodyPr/>
@@ -13534,7 +13398,7 @@
                   </a:tcPr>
                 </a:tc>
               </a:tr>
-              <a:tr h="508000">
+              <a:tr h="406400">
                 <a:tc>
                   <a:txBody>
                     <a:bodyPr/>
@@ -13565,9 +13429,9 @@
                     <a:lstStyle/>
                     <a:p>
                       <a:r>
-                        <a:rPr sz="1600" b="0">
+                        <a:rPr sz="1600" b="1">
                           <a:solidFill>
-                            <a:srgbClr val="FFFFFF"/>
+                            <a:srgbClr val="B39DDB"/>
                           </a:solidFill>
                           <a:latin typeface="Sarabun"/>
                           <a:ea typeface="Sarabun"/>
@@ -13584,7 +13448,7 @@
                   </a:tcPr>
                 </a:tc>
               </a:tr>
-              <a:tr h="508000">
+              <a:tr h="406400">
                 <a:tc>
                   <a:txBody>
                     <a:bodyPr/>
@@ -13634,7 +13498,7 @@
                   </a:tcPr>
                 </a:tc>
               </a:tr>
-              <a:tr h="508000">
+              <a:tr h="406400">
                 <a:tc>
                   <a:txBody>
                     <a:bodyPr/>
@@ -13684,7 +13548,7 @@
                   </a:tcPr>
                 </a:tc>
               </a:tr>
-              <a:tr h="508000">
+              <a:tr h="406400">
                 <a:tc>
                   <a:txBody>
                     <a:bodyPr/>
@@ -13740,14 +13604,14 @@
       </p:graphicFrame>
       <p:sp>
         <p:nvSpPr>
-          <p:cNvPr id="8" name="Rectangle 7"/>
+          <p:cNvPr id="9" name="Rectangle 8"/>
           <p:cNvSpPr/>
           <p:nvPr/>
         </p:nvSpPr>
         <p:spPr>
           <a:xfrm>
-            <a:off x="508000" y="5334000"/>
-            <a:ext cx="11176000" cy="558800"/>
+            <a:off x="508000" y="5232400"/>
+            <a:ext cx="11176000" cy="660400"/>
           </a:xfrm>
           <a:prstGeom prst="rect">
             <a:avLst/>
@@ -13784,14 +13648,14 @@
       </p:sp>
       <p:sp>
         <p:nvSpPr>
-          <p:cNvPr id="9" name="TextBox 8"/>
+          <p:cNvPr id="10" name="TextBox 9"/>
           <p:cNvSpPr txBox="1"/>
           <p:nvPr/>
         </p:nvSpPr>
         <p:spPr>
           <a:xfrm>
-            <a:off x="635000" y="5384800"/>
-            <a:ext cx="10922000" cy="457200"/>
+            <a:off x="635000" y="5283200"/>
+            <a:ext cx="10922000" cy="558800"/>
           </a:xfrm>
           <a:prstGeom prst="rect">
             <a:avLst/>
@@ -13804,13 +13668,13 @@
           </a:bodyPr>
           <a:lstStyle/>
           <a:p>
-            <a:pPr algn="l">
+            <a:pPr algn="ctr">
               <a:spcAft>
                 <a:spcPts val="600"/>
               </a:spcAft>
             </a:pPr>
             <a:r>
-              <a:rPr sz="1700" b="1">
+              <a:rPr sz="1600" b="1">
                 <a:solidFill>
                   <a:srgbClr val="FFFFFF"/>
                 </a:solidFill>
@@ -13818,14 +13682,14 @@
                 <a:ea typeface="Sarabun"/>
                 <a:cs typeface="Sarabun"/>
               </a:rPr>
-              <a:t>ลูกความไม่มี username/password จึงไม่ใช่ SystemUser ตามหลัก is-a</a:t>
-            </a:r>
-          </a:p>
-        </p:txBody>
-      </p:sp>
-      <p:sp>
-        <p:nvSpPr>
-          <p:cNvPr id="10" name="TextBox 9"/>
+              <a:t>ผลที่ได้: Lawyer มี name/phone โดยไม่ต้องเขียนซ้ำ · Client ไม่ใช่ SystemUser</a:t>
+            </a:r>
+          </a:p>
+        </p:txBody>
+      </p:sp>
+      <p:sp>
+        <p:nvSpPr>
+          <p:cNvPr id="11" name="TextBox 10"/>
           <p:cNvSpPr txBox="1"/>
           <p:nvPr/>
         </p:nvSpPr>
@@ -13926,7 +13790,7 @@
                 <a:ea typeface="Sarabun"/>
                 <a:cs typeface="Sarabun"/>
               </a:rPr>
-              <a:t>เมธอดเดียว ผลต่างตามคลาส: home_url() · reminder_lead_days()</a:t>
+              <a:t>เรียก home_url() ชื่อเดียว ได้หน้าแรกตามบทบาท</a:t>
             </a:r>
           </a:p>
         </p:txBody>
@@ -14103,14 +13967,55 @@
       </p:sp>
       <p:sp>
         <p:nvSpPr>
-          <p:cNvPr id="7" name="Rectangle 6"/>
+          <p:cNvPr id="7" name="TextBox 6"/>
+          <p:cNvSpPr txBox="1"/>
+          <p:nvPr/>
+        </p:nvSpPr>
+        <p:spPr>
+          <a:xfrm>
+            <a:off x="508000" y="1371600"/>
+            <a:ext cx="11176000" cy="381000"/>
+          </a:xfrm>
+          <a:prstGeom prst="rect">
+            <a:avLst/>
+          </a:prstGeom>
+          <a:noFill/>
+        </p:spPr>
+        <p:txBody>
+          <a:bodyPr wrap="square" anchor="t" lIns="50800" rIns="50800" tIns="25400" bIns="25400">
+            <a:spAutoFit/>
+          </a:bodyPr>
+          <a:lstStyle/>
+          <a:p>
+            <a:pPr algn="l">
+              <a:spcAft>
+                <a:spcPts val="600"/>
+              </a:spcAft>
+            </a:pPr>
+            <a:r>
+              <a:rPr sz="1800" b="1">
+                <a:solidFill>
+                  <a:srgbClr val="B39DDB"/>
+                </a:solidFill>
+                <a:latin typeface="Sarabun"/>
+                <a:ea typeface="Sarabun"/>
+                <a:cs typeface="Sarabun"/>
+              </a:rPr>
+              <a:t>เรียกเมธอดชื่อเดียว แต่ละคลาสตอบไม่เหมือนกัน</a:t>
+            </a:r>
+          </a:p>
+        </p:txBody>
+      </p:sp>
+      <p:sp>
+        <p:nvSpPr>
+          <p:cNvPr id="8" name="Rectangle 7"/>
           <p:cNvSpPr/>
           <p:nvPr/>
         </p:nvSpPr>
         <p:spPr>
           <a:xfrm>
-            <a:off x="508000" y="1524000"/>
-            <a:ext cx="5461000" cy="2921000"/>
+            <a:off x="508000" y="1803400"/>
+            <a:ext cx="6858000" cy="3048000"/>
           </a:xfrm>
           <a:prstGeom prst="rect">
             <a:avLst/>
@@ -14149,14 +14054,14 @@
       </p:sp>
       <p:sp>
         <p:nvSpPr>
-          <p:cNvPr id="8" name="TextBox 7"/>
+          <p:cNvPr id="9" name="TextBox 8"/>
           <p:cNvSpPr txBox="1"/>
           <p:nvPr/>
         </p:nvSpPr>
         <p:spPr>
           <a:xfrm>
-            <a:off x="635000" y="1625600"/>
-            <a:ext cx="5207000" cy="2717800"/>
+            <a:off x="635000" y="1905000"/>
+            <a:ext cx="6604000" cy="2844800"/>
           </a:xfrm>
           <a:prstGeom prst="rect">
             <a:avLst/>
@@ -14175,7 +14080,7 @@
               </a:spcAft>
             </a:pPr>
             <a:r>
-              <a:rPr sz="1300" b="0">
+              <a:rPr sz="1400" b="0">
                 <a:solidFill>
                   <a:srgbClr val="A6A6A6"/>
                 </a:solidFill>
@@ -14193,7 +14098,7 @@
               </a:spcAft>
             </a:pPr>
             <a:r>
-              <a:rPr sz="1300" b="0">
+              <a:rPr sz="1400" b="0">
                 <a:solidFill>
                   <a:srgbClr val="FFFFFF"/>
                 </a:solidFill>
@@ -14211,7 +14116,7 @@
               </a:spcAft>
             </a:pPr>
             <a:r>
-              <a:rPr sz="1300" b="0">
+              <a:rPr sz="1400" b="0">
                 <a:solidFill>
                   <a:srgbClr val="FFFFFF"/>
                 </a:solidFill>
@@ -14229,7 +14134,25 @@
               </a:spcAft>
             </a:pPr>
             <a:r>
-              <a:rPr sz="1300" b="0">
+              <a:rPr sz="1400" b="1">
+                <a:solidFill>
+                  <a:srgbClr val="B39DDB"/>
+                </a:solidFill>
+                <a:latin typeface="Menlo"/>
+                <a:ea typeface="Sarabun"/>
+                <a:cs typeface="Sarabun"/>
+              </a:rPr>
+              <a:t>        return "/schedule/today"</a:t>
+            </a:r>
+          </a:p>
+          <a:p>
+            <a:pPr algn="l">
+              <a:spcAft>
+                <a:spcPts val="200"/>
+              </a:spcAft>
+            </a:pPr>
+            <a:r>
+              <a:rPr sz="1400" b="0">
                 <a:solidFill>
                   <a:srgbClr val="FFFFFF"/>
                 </a:solidFill>
@@ -14237,7 +14160,7 @@
                 <a:ea typeface="Sarabun"/>
                 <a:cs typeface="Sarabun"/>
               </a:rPr>
-              <a:t>        return "/schedule/today"</a:t>
+              <a:t>class Manager(SystemUser):</a:t>
             </a:r>
           </a:p>
           <a:p>
@@ -14247,7 +14170,7 @@
               </a:spcAft>
             </a:pPr>
             <a:r>
-              <a:rPr sz="1300" b="0">
+              <a:rPr sz="1400" b="0">
                 <a:solidFill>
                   <a:srgbClr val="FFFFFF"/>
                 </a:solidFill>
@@ -14255,7 +14178,7 @@
                 <a:ea typeface="Sarabun"/>
                 <a:cs typeface="Sarabun"/>
               </a:rPr>
-              <a:t>class Manager(SystemUser):</a:t>
+              <a:t>    def home_url(self) -&gt; str:</a:t>
             </a:r>
           </a:p>
           <a:p>
@@ -14265,7 +14188,25 @@
               </a:spcAft>
             </a:pPr>
             <a:r>
-              <a:rPr sz="1300" b="0">
+              <a:rPr sz="1400" b="1">
+                <a:solidFill>
+                  <a:srgbClr val="B39DDB"/>
+                </a:solidFill>
+                <a:latin typeface="Menlo"/>
+                <a:ea typeface="Sarabun"/>
+                <a:cs typeface="Sarabun"/>
+              </a:rPr>
+              <a:t>        return "/manager/dashboard"</a:t>
+            </a:r>
+          </a:p>
+          <a:p>
+            <a:pPr algn="l">
+              <a:spcAft>
+                <a:spcPts val="200"/>
+              </a:spcAft>
+            </a:pPr>
+            <a:r>
+              <a:rPr sz="1400" b="0">
                 <a:solidFill>
                   <a:srgbClr val="FFFFFF"/>
                 </a:solidFill>
@@ -14273,6 +14214,24 @@
                 <a:ea typeface="Sarabun"/>
                 <a:cs typeface="Sarabun"/>
               </a:rPr>
+              <a:t>class Admin(SystemUser):</a:t>
+            </a:r>
+          </a:p>
+          <a:p>
+            <a:pPr algn="l">
+              <a:spcAft>
+                <a:spcPts val="200"/>
+              </a:spcAft>
+            </a:pPr>
+            <a:r>
+              <a:rPr sz="1400" b="0">
+                <a:solidFill>
+                  <a:srgbClr val="FFFFFF"/>
+                </a:solidFill>
+                <a:latin typeface="Menlo"/>
+                <a:ea typeface="Sarabun"/>
+                <a:cs typeface="Sarabun"/>
+              </a:rPr>
               <a:t>    def home_url(self) -&gt; str:</a:t>
             </a:r>
           </a:p>
@@ -14283,68 +14242,14 @@
               </a:spcAft>
             </a:pPr>
             <a:r>
-              <a:rPr sz="1300" b="0">
-                <a:solidFill>
-                  <a:srgbClr val="FFFFFF"/>
+              <a:rPr sz="1400" b="1">
+                <a:solidFill>
+                  <a:srgbClr val="B39DDB"/>
                 </a:solidFill>
                 <a:latin typeface="Menlo"/>
                 <a:ea typeface="Sarabun"/>
                 <a:cs typeface="Sarabun"/>
               </a:rPr>
-              <a:t>        return "/manager/dashboard"</a:t>
-            </a:r>
-          </a:p>
-          <a:p>
-            <a:pPr algn="l">
-              <a:spcAft>
-                <a:spcPts val="200"/>
-              </a:spcAft>
-            </a:pPr>
-            <a:r>
-              <a:rPr sz="1300" b="0">
-                <a:solidFill>
-                  <a:srgbClr val="FFFFFF"/>
-                </a:solidFill>
-                <a:latin typeface="Menlo"/>
-                <a:ea typeface="Sarabun"/>
-                <a:cs typeface="Sarabun"/>
-              </a:rPr>
-              <a:t>class Admin(SystemUser):</a:t>
-            </a:r>
-          </a:p>
-          <a:p>
-            <a:pPr algn="l">
-              <a:spcAft>
-                <a:spcPts val="200"/>
-              </a:spcAft>
-            </a:pPr>
-            <a:r>
-              <a:rPr sz="1300" b="0">
-                <a:solidFill>
-                  <a:srgbClr val="FFFFFF"/>
-                </a:solidFill>
-                <a:latin typeface="Menlo"/>
-                <a:ea typeface="Sarabun"/>
-                <a:cs typeface="Sarabun"/>
-              </a:rPr>
-              <a:t>    def home_url(self) -&gt; str:</a:t>
-            </a:r>
-          </a:p>
-          <a:p>
-            <a:pPr algn="l">
-              <a:spcAft>
-                <a:spcPts val="200"/>
-              </a:spcAft>
-            </a:pPr>
-            <a:r>
-              <a:rPr sz="1300" b="0">
-                <a:solidFill>
-                  <a:srgbClr val="FFFFFF"/>
-                </a:solidFill>
-                <a:latin typeface="Menlo"/>
-                <a:ea typeface="Sarabun"/>
-                <a:cs typeface="Sarabun"/>
-              </a:rPr>
               <a:t>        return "/admin/dashboard"</a:t>
             </a:r>
           </a:p>
@@ -14352,14 +14257,14 @@
       </p:sp>
       <p:sp>
         <p:nvSpPr>
-          <p:cNvPr id="9" name="Rectangle 8"/>
+          <p:cNvPr id="10" name="Rectangle 9"/>
           <p:cNvSpPr/>
           <p:nvPr/>
         </p:nvSpPr>
         <p:spPr>
           <a:xfrm>
-            <a:off x="508000" y="4597400"/>
-            <a:ext cx="5461000" cy="990600"/>
+            <a:off x="7620000" y="1803400"/>
+            <a:ext cx="4064000" cy="1397000"/>
           </a:xfrm>
           <a:prstGeom prst="rect">
             <a:avLst/>
@@ -14398,14 +14303,14 @@
       </p:sp>
       <p:sp>
         <p:nvSpPr>
-          <p:cNvPr id="10" name="TextBox 9"/>
+          <p:cNvPr id="11" name="TextBox 10"/>
           <p:cNvSpPr txBox="1"/>
           <p:nvPr/>
         </p:nvSpPr>
         <p:spPr>
           <a:xfrm>
-            <a:off x="635000" y="4699000"/>
-            <a:ext cx="5207000" cy="787400"/>
+            <a:off x="7747000" y="1905000"/>
+            <a:ext cx="3810000" cy="1193800"/>
           </a:xfrm>
           <a:prstGeom prst="rect">
             <a:avLst/>
@@ -14424,7 +14329,7 @@
               </a:spcAft>
             </a:pPr>
             <a:r>
-              <a:rPr sz="1300" b="0">
+              <a:rPr sz="1600" b="0">
                 <a:solidFill>
                   <a:srgbClr val="A6A6A6"/>
                 </a:solidFill>
@@ -14442,7 +14347,7 @@
               </a:spcAft>
             </a:pPr>
             <a:r>
-              <a:rPr sz="1300" b="0">
+              <a:rPr sz="1600" b="0">
                 <a:solidFill>
                   <a:srgbClr val="FFFFFF"/>
                 </a:solidFill>
@@ -14460,7 +14365,7 @@
               </a:spcAft>
             </a:pPr>
             <a:r>
-              <a:rPr sz="1300" b="0">
+              <a:rPr sz="1600" b="0">
                 <a:solidFill>
                   <a:srgbClr val="FFFFFF"/>
                 </a:solidFill>
@@ -14475,25 +14380,23 @@
       </p:sp>
       <p:sp>
         <p:nvSpPr>
-          <p:cNvPr id="11" name="Rectangle 10"/>
+          <p:cNvPr id="12" name="Rectangle 11"/>
           <p:cNvSpPr/>
           <p:nvPr/>
         </p:nvSpPr>
         <p:spPr>
           <a:xfrm>
-            <a:off x="6223000" y="1524000"/>
-            <a:ext cx="5461000" cy="2921000"/>
+            <a:off x="508000" y="5029200"/>
+            <a:ext cx="11176000" cy="558800"/>
           </a:xfrm>
           <a:prstGeom prst="rect">
             <a:avLst/>
           </a:prstGeom>
           <a:solidFill>
-            <a:srgbClr val="161616"/>
+            <a:srgbClr val="362D4A"/>
           </a:solidFill>
-          <a:ln w="15875">
-            <a:solidFill>
-              <a:srgbClr val="444444"/>
-            </a:solidFill>
+          <a:ln>
+            <a:noFill/>
           </a:ln>
           <a:effectLst/>
         </p:spPr>
@@ -14521,14 +14424,55 @@
       </p:sp>
       <p:sp>
         <p:nvSpPr>
-          <p:cNvPr id="12" name="TextBox 11"/>
+          <p:cNvPr id="13" name="TextBox 12"/>
           <p:cNvSpPr txBox="1"/>
           <p:nvPr/>
         </p:nvSpPr>
         <p:spPr>
           <a:xfrm>
-            <a:off x="6350000" y="1625600"/>
-            <a:ext cx="5207000" cy="2717800"/>
+            <a:off x="635000" y="5080000"/>
+            <a:ext cx="10922000" cy="457200"/>
+          </a:xfrm>
+          <a:prstGeom prst="rect">
+            <a:avLst/>
+          </a:prstGeom>
+          <a:noFill/>
+        </p:spPr>
+        <p:txBody>
+          <a:bodyPr wrap="square" anchor="ctr" lIns="50800" rIns="50800" tIns="25400" bIns="25400">
+            <a:spAutoFit/>
+          </a:bodyPr>
+          <a:lstStyle/>
+          <a:p>
+            <a:pPr algn="ctr">
+              <a:spcAft>
+                <a:spcPts val="600"/>
+              </a:spcAft>
+            </a:pPr>
+            <a:r>
+              <a:rPr sz="1600" b="1">
+                <a:solidFill>
+                  <a:srgbClr val="FFFFFF"/>
+                </a:solidFill>
+                <a:latin typeface="Sarabun"/>
+                <a:ea typeface="Sarabun"/>
+                <a:cs typeface="Sarabun"/>
+              </a:rPr>
+              <a:t>ผลที่ได้: home_url() บรรทัดเดียว ได้หน้าแรก 3 แบบ (ดูภาพหน้า 3)</a:t>
+            </a:r>
+          </a:p>
+        </p:txBody>
+      </p:sp>
+      <p:sp>
+        <p:nvSpPr>
+          <p:cNvPr id="14" name="TextBox 13"/>
+          <p:cNvSpPr txBox="1"/>
+          <p:nvPr/>
+        </p:nvSpPr>
+        <p:spPr>
+          <a:xfrm>
+            <a:off x="508000" y="6070600"/>
+            <a:ext cx="11176000" cy="279400"/>
           </a:xfrm>
           <a:prstGeom prst="rect">
             <a:avLst/>
@@ -14543,327 +14487,19 @@
           <a:p>
             <a:pPr algn="l">
               <a:spcAft>
-                <a:spcPts val="200"/>
-              </a:spcAft>
-            </a:pPr>
-            <a:r>
-              <a:rPr sz="1300" b="0">
+                <a:spcPts val="600"/>
+              </a:spcAft>
+            </a:pPr>
+            <a:r>
+              <a:rPr sz="1200" b="0">
                 <a:solidFill>
                   <a:srgbClr val="A6A6A6"/>
                 </a:solidFill>
-                <a:latin typeface="Menlo"/>
-                <a:ea typeface="Sarabun"/>
-                <a:cs typeface="Sarabun"/>
-              </a:rPr>
-              <a:t># domain/appointment.py:86,102,114</a:t>
-            </a:r>
-          </a:p>
-          <a:p>
-            <a:pPr algn="l">
-              <a:spcAft>
-                <a:spcPts val="200"/>
-              </a:spcAft>
-            </a:pPr>
-            <a:r>
-              <a:rPr sz="1300" b="0">
-                <a:solidFill>
-                  <a:srgbClr val="FFFFFF"/>
-                </a:solidFill>
-                <a:latin typeface="Menlo"/>
-                <a:ea typeface="Sarabun"/>
-                <a:cs typeface="Sarabun"/>
-              </a:rPr>
-              <a:t>class CourtHearing(Appointment):</a:t>
-            </a:r>
-          </a:p>
-          <a:p>
-            <a:pPr algn="l">
-              <a:spcAft>
-                <a:spcPts val="200"/>
-              </a:spcAft>
-            </a:pPr>
-            <a:r>
-              <a:rPr sz="1300" b="0">
-                <a:solidFill>
-                  <a:srgbClr val="FFFFFF"/>
-                </a:solidFill>
-                <a:latin typeface="Menlo"/>
-                <a:ea typeface="Sarabun"/>
-                <a:cs typeface="Sarabun"/>
-              </a:rPr>
-              <a:t>    def reminder_lead_days(self):</a:t>
-            </a:r>
-          </a:p>
-          <a:p>
-            <a:pPr algn="l">
-              <a:spcAft>
-                <a:spcPts val="200"/>
-              </a:spcAft>
-            </a:pPr>
-            <a:r>
-              <a:rPr sz="1300" b="0">
-                <a:solidFill>
-                  <a:srgbClr val="FFFFFF"/>
-                </a:solidFill>
-                <a:latin typeface="Menlo"/>
-                <a:ea typeface="Sarabun"/>
-                <a:cs typeface="Sarabun"/>
-              </a:rPr>
-              <a:t>        return 3</a:t>
-            </a:r>
-          </a:p>
-          <a:p>
-            <a:pPr algn="l">
-              <a:spcAft>
-                <a:spcPts val="200"/>
-              </a:spcAft>
-            </a:pPr>
-            <a:r>
-              <a:rPr sz="1300" b="0">
-                <a:solidFill>
-                  <a:srgbClr val="FFFFFF"/>
-                </a:solidFill>
-                <a:latin typeface="Menlo"/>
-                <a:ea typeface="Sarabun"/>
-                <a:cs typeface="Sarabun"/>
-              </a:rPr>
-              <a:t>class ClientMeeting(Appointment):</a:t>
-            </a:r>
-          </a:p>
-          <a:p>
-            <a:pPr algn="l">
-              <a:spcAft>
-                <a:spcPts val="200"/>
-              </a:spcAft>
-            </a:pPr>
-            <a:r>
-              <a:rPr sz="1300" b="0">
-                <a:solidFill>
-                  <a:srgbClr val="FFFFFF"/>
-                </a:solidFill>
-                <a:latin typeface="Menlo"/>
-                <a:ea typeface="Sarabun"/>
-                <a:cs typeface="Sarabun"/>
-              </a:rPr>
-              <a:t>    def reminder_lead_days(self):</a:t>
-            </a:r>
-          </a:p>
-          <a:p>
-            <a:pPr algn="l">
-              <a:spcAft>
-                <a:spcPts val="200"/>
-              </a:spcAft>
-            </a:pPr>
-            <a:r>
-              <a:rPr sz="1300" b="0">
-                <a:solidFill>
-                  <a:srgbClr val="FFFFFF"/>
-                </a:solidFill>
-                <a:latin typeface="Menlo"/>
-                <a:ea typeface="Sarabun"/>
-                <a:cs typeface="Sarabun"/>
-              </a:rPr>
-              <a:t>        return 1</a:t>
-            </a:r>
-          </a:p>
-          <a:p>
-            <a:pPr algn="l">
-              <a:spcAft>
-                <a:spcPts val="200"/>
-              </a:spcAft>
-            </a:pPr>
-            <a:r>
-              <a:rPr sz="1300" b="0">
-                <a:solidFill>
-                  <a:srgbClr val="FFFFFF"/>
-                </a:solidFill>
-                <a:latin typeface="Menlo"/>
-                <a:ea typeface="Sarabun"/>
-                <a:cs typeface="Sarabun"/>
-              </a:rPr>
-              <a:t>class FilingDeadline(Appointment):</a:t>
-            </a:r>
-          </a:p>
-          <a:p>
-            <a:pPr algn="l">
-              <a:spcAft>
-                <a:spcPts val="200"/>
-              </a:spcAft>
-            </a:pPr>
-            <a:r>
-              <a:rPr sz="1300" b="0">
-                <a:solidFill>
-                  <a:srgbClr val="FFFFFF"/>
-                </a:solidFill>
-                <a:latin typeface="Menlo"/>
-                <a:ea typeface="Sarabun"/>
-                <a:cs typeface="Sarabun"/>
-              </a:rPr>
-              <a:t>    def reminder_lead_days(self):</a:t>
-            </a:r>
-          </a:p>
-          <a:p>
-            <a:pPr algn="l">
-              <a:spcAft>
-                <a:spcPts val="200"/>
-              </a:spcAft>
-            </a:pPr>
-            <a:r>
-              <a:rPr sz="1300" b="0">
-                <a:solidFill>
-                  <a:srgbClr val="FFFFFF"/>
-                </a:solidFill>
-                <a:latin typeface="Menlo"/>
-                <a:ea typeface="Sarabun"/>
-                <a:cs typeface="Sarabun"/>
-              </a:rPr>
-              <a:t>        return 15</a:t>
-            </a:r>
-          </a:p>
-        </p:txBody>
-      </p:sp>
-      <p:sp>
-        <p:nvSpPr>
-          <p:cNvPr id="13" name="Rectangle 12"/>
-          <p:cNvSpPr/>
-          <p:nvPr/>
-        </p:nvSpPr>
-        <p:spPr>
-          <a:xfrm>
-            <a:off x="6223000" y="4597400"/>
-            <a:ext cx="5461000" cy="990600"/>
-          </a:xfrm>
-          <a:prstGeom prst="rect">
-            <a:avLst/>
-          </a:prstGeom>
-          <a:solidFill>
-            <a:srgbClr val="161616"/>
-          </a:solidFill>
-          <a:ln w="15875">
-            <a:solidFill>
-              <a:srgbClr val="444444"/>
-            </a:solidFill>
-          </a:ln>
-          <a:effectLst/>
-        </p:spPr>
-        <p:style>
-          <a:lnRef idx="1">
-            <a:schemeClr val="accent1"/>
-          </a:lnRef>
-          <a:fillRef idx="3">
-            <a:schemeClr val="accent1"/>
-          </a:fillRef>
-          <a:effectRef idx="2">
-            <a:schemeClr val="accent1"/>
-          </a:effectRef>
-          <a:fontRef idx="minor">
-            <a:schemeClr val="lt1"/>
-          </a:fontRef>
-        </p:style>
-        <p:txBody>
-          <a:bodyPr rtlCol="0" anchor="ctr"/>
-          <a:lstStyle/>
-          <a:p>
-            <a:pPr algn="ctr"/>
-          </a:p>
-        </p:txBody>
-      </p:sp>
-      <p:sp>
-        <p:nvSpPr>
-          <p:cNvPr id="14" name="TextBox 13"/>
-          <p:cNvSpPr txBox="1"/>
-          <p:nvPr/>
-        </p:nvSpPr>
-        <p:spPr>
-          <a:xfrm>
-            <a:off x="6350000" y="4699000"/>
-            <a:ext cx="5207000" cy="787400"/>
-          </a:xfrm>
-          <a:prstGeom prst="rect">
-            <a:avLst/>
-          </a:prstGeom>
-          <a:noFill/>
-        </p:spPr>
-        <p:txBody>
-          <a:bodyPr wrap="square" anchor="t" lIns="50800" rIns="50800" tIns="25400" bIns="25400">
-            <a:spAutoFit/>
-          </a:bodyPr>
-          <a:lstStyle/>
-          <a:p>
-            <a:pPr algn="l">
-              <a:spcAft>
-                <a:spcPts val="200"/>
-              </a:spcAft>
-            </a:pPr>
-            <a:r>
-              <a:rPr sz="1300" b="0">
-                <a:solidFill>
-                  <a:srgbClr val="FFFFFF"/>
-                </a:solidFill>
-                <a:latin typeface="Menlo"/>
-                <a:ea typeface="Sarabun"/>
-                <a:cs typeface="Sarabun"/>
-              </a:rPr>
-              <a:t>days = appt.reminder_lead_days()</a:t>
-            </a:r>
-          </a:p>
-          <a:p>
-            <a:pPr algn="l">
-              <a:spcAft>
-                <a:spcPts val="200"/>
-              </a:spcAft>
-            </a:pPr>
-            <a:r>
-              <a:rPr sz="1300" b="0">
-                <a:solidFill>
-                  <a:srgbClr val="A6A6A6"/>
-                </a:solidFill>
-                <a:latin typeface="Menlo"/>
-                <a:ea typeface="Sarabun"/>
-                <a:cs typeface="Sarabun"/>
-              </a:rPr>
-              <a:t># ชนิดไหนก็เรียกบรรทัดเดียว</a:t>
-            </a:r>
-          </a:p>
-        </p:txBody>
-      </p:sp>
-      <p:sp>
-        <p:nvSpPr>
-          <p:cNvPr id="15" name="TextBox 14"/>
-          <p:cNvSpPr txBox="1"/>
-          <p:nvPr/>
-        </p:nvSpPr>
-        <p:spPr>
-          <a:xfrm>
-            <a:off x="508000" y="6070600"/>
-            <a:ext cx="11176000" cy="279400"/>
-          </a:xfrm>
-          <a:prstGeom prst="rect">
-            <a:avLst/>
-          </a:prstGeom>
-          <a:noFill/>
-        </p:spPr>
-        <p:txBody>
-          <a:bodyPr wrap="square" anchor="t" lIns="50800" rIns="50800" tIns="25400" bIns="25400">
-            <a:spAutoFit/>
-          </a:bodyPr>
-          <a:lstStyle/>
-          <a:p>
-            <a:pPr algn="l">
-              <a:spcAft>
-                <a:spcPts val="600"/>
-              </a:spcAft>
-            </a:pPr>
-            <a:r>
-              <a:rPr sz="1200" b="0">
-                <a:solidFill>
-                  <a:srgbClr val="A6A6A6"/>
-                </a:solidFill>
                 <a:latin typeface="Sarabun"/>
                 <a:ea typeface="Sarabun"/>
                 <a:cs typeface="Sarabun"/>
               </a:rPr>
-              <a:t>อ้างอิง: domain/person.py · domain/appointment.py · api/routes/dashboard.py (ตัดบางบรรทัด)</a:t>
+              <a:t>อ้างอิง: domain/person.py · api/routes/dashboard.py (ตัดบางบรรทัด)</a:t>
             </a:r>
           </a:p>
         </p:txBody>
@@ -15113,8 +14749,8 @@
         </p:nvSpPr>
         <p:spPr>
           <a:xfrm>
-            <a:off x="508000" y="1460500"/>
-            <a:ext cx="11176000" cy="355600"/>
+            <a:off x="508000" y="1371600"/>
+            <a:ext cx="11176000" cy="381000"/>
           </a:xfrm>
           <a:prstGeom prst="rect">
             <a:avLst/>
@@ -15133,15 +14769,15 @@
               </a:spcAft>
             </a:pPr>
             <a:r>
-              <a:rPr sz="1700" b="0">
-                <a:solidFill>
-                  <a:srgbClr val="FFFFFF"/>
+              <a:rPr sz="1800" b="1">
+                <a:solidFill>
+                  <a:srgbClr val="B39DDB"/>
                 </a:solidFill>
                 <a:latin typeface="Sarabun"/>
                 <a:ea typeface="Sarabun"/>
                 <a:cs typeface="Sarabun"/>
               </a:rPr>
-              <a:t>เลื่อนทีละขั้น (BR-7) · ยื่นฟ้องต้องมีทนายรับแล้ว (BR-18) · ผิดสถานะโยน error</a:t>
+              <a:t>ข้อมูลสำคัญแก้ได้ผ่านเมธอดที่ตรวจกฎเท่านั้น</a:t>
             </a:r>
           </a:p>
         </p:txBody>
@@ -15154,7 +14790,7 @@
         </p:nvSpPr>
         <p:spPr>
           <a:xfrm>
-            <a:off x="508000" y="1905000"/>
+            <a:off x="508000" y="1803400"/>
             <a:ext cx="5588000" cy="2095500"/>
           </a:xfrm>
           <a:prstGeom prst="rect">
@@ -15200,7 +14836,7 @@
         </p:nvSpPr>
         <p:spPr>
           <a:xfrm>
-            <a:off x="635000" y="2006600"/>
+            <a:off x="635000" y="1905000"/>
             <a:ext cx="5334000" cy="1892300"/>
           </a:xfrm>
           <a:prstGeom prst="rect">
@@ -15300,7 +14936,7 @@
                 <a:ea typeface="Sarabun"/>
                 <a:cs typeface="Sarabun"/>
               </a:rPr>
-              <a:t># ไม่มี setter: แก้ตรงได้ AttributeError</a:t>
+              <a:t>    # ไม่มี setter: แก้ตรงได้ AttributeError</a:t>
             </a:r>
           </a:p>
           <a:p>
@@ -15336,7 +14972,7 @@
                 <a:ea typeface="Sarabun"/>
                 <a:cs typeface="Sarabun"/>
               </a:rPr>
-              <a:t>    # ตรวจ BR-7 / BR-18 ก่อน</a:t>
+              <a:t>    # ตรวจกฎก่อนเปลี่ยนสถานะ</a:t>
             </a:r>
           </a:p>
           <a:p>
@@ -15346,9 +14982,9 @@
               </a:spcAft>
             </a:pPr>
             <a:r>
-              <a:rPr sz="1200" b="0">
-                <a:solidFill>
-                  <a:srgbClr val="FFFFFF"/>
+              <a:rPr sz="1200" b="1">
+                <a:solidFill>
+                  <a:srgbClr val="B39DDB"/>
                 </a:solidFill>
                 <a:latin typeface="Menlo"/>
                 <a:ea typeface="Sarabun"/>
@@ -15367,7 +15003,7 @@
         </p:nvSpPr>
         <p:spPr>
           <a:xfrm>
-            <a:off x="508000" y="4127500"/>
+            <a:off x="508000" y="4025900"/>
             <a:ext cx="5588000" cy="1270000"/>
           </a:xfrm>
           <a:prstGeom prst="rect">
@@ -15413,7 +15049,7 @@
         </p:nvSpPr>
         <p:spPr>
           <a:xfrm>
-            <a:off x="635000" y="4229100"/>
+            <a:off x="635000" y="4127500"/>
             <a:ext cx="5334000" cy="1066800"/>
           </a:xfrm>
           <a:prstGeom prst="rect">
@@ -15487,9 +15123,9 @@
               </a:spcAft>
             </a:pPr>
             <a:r>
-              <a:rPr sz="1200" b="0">
-                <a:solidFill>
-                  <a:srgbClr val="FFFFFF"/>
+              <a:rPr sz="1200" b="1">
+                <a:solidFill>
+                  <a:srgbClr val="B39DDB"/>
                 </a:solidFill>
                 <a:latin typeface="Menlo"/>
                 <a:ea typeface="Sarabun"/>
@@ -15508,8 +15144,8 @@
         </p:nvSpPr>
         <p:spPr>
           <a:xfrm>
-            <a:off x="508000" y="5486400"/>
-            <a:ext cx="5588000" cy="508000"/>
+            <a:off x="6350000" y="4699000"/>
+            <a:ext cx="5334000" cy="533400"/>
           </a:xfrm>
           <a:prstGeom prst="rect">
             <a:avLst/>
@@ -15549,8 +15185,8 @@
         </p:nvSpPr>
         <p:spPr>
           <a:xfrm>
-            <a:off x="6330950" y="1887409"/>
-            <a:ext cx="5372100" cy="3591181"/>
+            <a:off x="6900728" y="1784350"/>
+            <a:ext cx="4232542" cy="2832100"/>
           </a:xfrm>
           <a:prstGeom prst="rect">
             <a:avLst/>
@@ -15602,8 +15238,8 @@
         </p:blipFill>
         <p:spPr>
           <a:xfrm>
-            <a:off x="6350000" y="1906459"/>
-            <a:ext cx="5334000" cy="3553081"/>
+            <a:off x="6919778" y="1803400"/>
+            <a:ext cx="4194442" cy="2794000"/>
           </a:xfrm>
           <a:prstGeom prst="rect">
             <a:avLst/>
@@ -15612,14 +15248,58 @@
       </p:pic>
       <p:sp>
         <p:nvSpPr>
-          <p:cNvPr id="15" name="TextBox 14"/>
+          <p:cNvPr id="15" name="Rectangle 14"/>
+          <p:cNvSpPr/>
+          <p:nvPr/>
+        </p:nvSpPr>
+        <p:spPr>
+          <a:xfrm>
+            <a:off x="508000" y="5334000"/>
+            <a:ext cx="11176000" cy="508000"/>
+          </a:xfrm>
+          <a:prstGeom prst="rect">
+            <a:avLst/>
+          </a:prstGeom>
+          <a:solidFill>
+            <a:srgbClr val="362D4A"/>
+          </a:solidFill>
+          <a:ln>
+            <a:noFill/>
+          </a:ln>
+          <a:effectLst/>
+        </p:spPr>
+        <p:style>
+          <a:lnRef idx="1">
+            <a:schemeClr val="accent1"/>
+          </a:lnRef>
+          <a:fillRef idx="3">
+            <a:schemeClr val="accent1"/>
+          </a:fillRef>
+          <a:effectRef idx="2">
+            <a:schemeClr val="accent1"/>
+          </a:effectRef>
+          <a:fontRef idx="minor">
+            <a:schemeClr val="lt1"/>
+          </a:fontRef>
+        </p:style>
+        <p:txBody>
+          <a:bodyPr rtlCol="0" anchor="ctr"/>
+          <a:lstStyle/>
+          <a:p>
+            <a:pPr algn="ctr"/>
+          </a:p>
+        </p:txBody>
+      </p:sp>
+      <p:sp>
+        <p:nvSpPr>
+          <p:cNvPr id="16" name="TextBox 15"/>
           <p:cNvSpPr txBox="1"/>
           <p:nvPr/>
         </p:nvSpPr>
         <p:spPr>
           <a:xfrm>
-            <a:off x="6350000" y="5537200"/>
-            <a:ext cx="5334000" cy="457200"/>
+            <a:off x="635000" y="5384800"/>
+            <a:ext cx="10922000" cy="406400"/>
           </a:xfrm>
           <a:prstGeom prst="rect">
             <a:avLst/>
@@ -15627,7 +15307,7 @@
           <a:noFill/>
         </p:spPr>
         <p:txBody>
-          <a:bodyPr wrap="square" anchor="t" lIns="50800" rIns="50800" tIns="25400" bIns="25400">
+          <a:bodyPr wrap="square" anchor="ctr" lIns="50800" rIns="50800" tIns="25400" bIns="25400">
             <a:spAutoFit/>
           </a:bodyPr>
           <a:lstStyle/>
@@ -15638,22 +15318,22 @@
               </a:spcAft>
             </a:pPr>
             <a:r>
-              <a:rPr sz="1300" b="1">
-                <a:solidFill>
-                  <a:srgbClr val="B39DDB"/>
+              <a:rPr sz="1600" b="1">
+                <a:solidFill>
+                  <a:srgbClr val="FFFFFF"/>
                 </a:solidFill>
                 <a:latin typeface="Sarabun"/>
                 <a:ea typeface="Sarabun"/>
                 <a:cs typeface="Sarabun"/>
               </a:rPr>
-              <a:t>หน้าคดีจริง: ขั้นสืบพยาน ปุ่มเสนอแค่ขั้นถัดไป "ตัดสิน"</a:t>
-            </a:r>
-          </a:p>
-        </p:txBody>
-      </p:sp>
-      <p:sp>
-        <p:nvSpPr>
-          <p:cNvPr id="16" name="TextBox 15"/>
+              <a:t>ผลที่ได้: ข้ามขั้นไม่ได้ ปุ่มเสนอแค่ขั้นถัดไป "ตัดสิน"</a:t>
+            </a:r>
+          </a:p>
+        </p:txBody>
+      </p:sp>
+      <p:sp>
+        <p:nvSpPr>
+          <p:cNvPr id="17" name="TextBox 16"/>
           <p:cNvSpPr txBox="1"/>
           <p:nvPr/>
         </p:nvSpPr>

</xml_diff>

<commit_message>
docs(slides): show real screens on encapsulation and exception slides
Slide 9 now shows the case status chip and the single "advance to next
status" button instead of the whole case page. Slide 10 uses its empty
space for a real schedule-conflict banner from the add-appointment form,
so the audience sees ScheduleConflictError become a Thai message.

Co-Authored-By: Claude Opus 5.5 <noreply@anthropic.com>
</commit_message>
<xml_diff>
--- a/docs/slides/LawFirm_Presentation.pptx
+++ b/docs/slides/LawFirm_Presentation.pptx
@@ -653,7 +653,7 @@
           <a:lstStyle/>
           <a:p>
             <a:r>
-              <a:t>Encapsulation สถานะของคดีกับสถานะการมอบหมายแก้ตรงจากข้างนอกไม่ได้ เก็บไว้ใน _status และเปิดให้อ่านผ่าน property status ที่ไม่มี setter ถ้าสั่ง case.status = ... จะได้ AttributeError การเปลี่ยนสถานะต้องผ่านเมธอดที่ตรวจกฎก่อน เช่น advance_status ต้องเลื่อนทีละขั้น และจะยื่นฟ้องได้ต้องมีทนายตอบรับแล้ว ถ้าผิดกฎจะโยน error ภาพขวาคือหน้าคดีจริง คดีนี้อยู่ขั้นสืบพยาน ปุ่มจึงเสนอแค่ขั้นถัดไปคือตัดสิน เพราะ advance_status ไม่ยอมให้ข้ามขั้น ข้อยกเว้นมีที่เดียวคือ repository ตั้ง _status ตรงตอนโหลดแถวเดิมจากฐาน ค่านั้นผ่านกฎมาแล้วตอนบันทึก จึงไม่ต้องตรวจซ้ำครับ</a:t>
+              <a:t>Encapsulation สถานะของคดีกับสถานะการมอบหมายแก้ตรงจากข้างนอกไม่ได้ เก็บไว้ใน _status และเปิดให้อ่านผ่าน property status ที่ไม่มี setter ถ้าสั่ง case.status = ... จะได้ AttributeError การเปลี่ยนสถานะต้องผ่านเมธอดที่ตรวจกฎก่อน เช่น advance_status ต้องเลื่อนทีละขั้น และจะยื่นฟ้องได้ต้องมีทนายตอบรับแล้ว ถ้าผิดกฎจะโยน error ภาพขวาบนคือหัวคดี ป้ายสถานะบอกว่าอยู่ขั้นสืบพยาน ภาพขวาล่างคือแผงจัดการคดี มีปุ่มม่วงปุ่มเดียวคือเลื่อนสถานะเป็นตัดสิน เพราะ advance_status ไม่ยอมให้ข้ามขั้น ข้อยกเว้นมีที่เดียวคือ repository ตั้ง _status ตรงตอนโหลดแถวเดิมจากฐาน ค่านั้นผ่านกฎมาแล้วตอนบันทึก จึงไม่ต้องตรวจซ้ำครับ</a:t>
             </a:r>
           </a:p>
         </p:txBody>
@@ -723,7 +723,7 @@
           <a:lstStyle/>
           <a:p>
             <a:r>
-              <a:t>Exception hierarchy error ทุกตัวในระบบเป็นคลาส มีแม่คือ DomainError และลูกสี่ตัวตามกลุ่มกฎ นัดชนตาม BR-1 เปลี่ยนสถานะผิดตาม BR-7 8 9 18 เลื่อนนัดไม่ได้ตาม BR-3 กับ 5 และการมอบหมายผิดกฎ BR-15 ถึง 19 ชั้น api ไม่มี handler กลาง แต่ละ route จับ subclass ของตัวเองแล้วแปลเป็นภาษาคน เช่น นัดชนก็แสดงฟอร์มเดิมพร้อมข้อความ หรือมอบหมายผิดก็ตอบ HTTP 409 เทสต้อง assert ชนิด subclass ที่เจาะจงครับ</a:t>
+              <a:t>Exception hierarchy error ทุกตัวในระบบเป็นคลาส มีแม่คือ DomainError และลูกสี่ตัวตามกลุ่มกฎ นัดชนตาม BR-1 เปลี่ยนสถานะผิดตาม BR-7 8 9 18 เลื่อนนัดไม่ได้ตาม BR-3 กับ 5 และการมอบหมายผิดกฎ BR-15 ถึง 19 ชั้น api ไม่มี handler กลาง แต่ละ route จับ subclass ของตัวเองแล้วแปลเป็นภาษาคน เช่น นัดชนก็แสดงฟอร์มเดิมพร้อมข้อความ หรือมอบหมายผิดก็ตอบ HTTP 409 เทสต้อง assert ชนิด subclass ที่เจาะจงครับ ตัวอย่างจริงอยู่กลางสไลด์ กรอกนัดพบลูกความทับเวลานัดเดิมของทนายคนเดียวกัน ระบบโยน ScheduleConflictError แล้วหน้าเว็บแสดงแถบแดงพร้อมข้อความนี้ ไม่ได้เงียบหายครับ</a:t>
             </a:r>
           </a:p>
         </p:txBody>
@@ -4830,8 +4830,8 @@
         </p:nvSpPr>
         <p:spPr>
           <a:xfrm>
-            <a:off x="508000" y="1587500"/>
-            <a:ext cx="5461000" cy="2413000"/>
+            <a:off x="508000" y="1549400"/>
+            <a:ext cx="5461000" cy="1968500"/>
           </a:xfrm>
           <a:prstGeom prst="rect">
             <a:avLst/>
@@ -4876,8 +4876,8 @@
         </p:nvSpPr>
         <p:spPr>
           <a:xfrm>
-            <a:off x="635000" y="1689100"/>
-            <a:ext cx="5207000" cy="2209800"/>
+            <a:off x="635000" y="1651000"/>
+            <a:ext cx="5207000" cy="1765300"/>
           </a:xfrm>
           <a:prstGeom prst="rect">
             <a:avLst/>
@@ -4896,7 +4896,7 @@
               </a:spcAft>
             </a:pPr>
             <a:r>
-              <a:rPr sz="1400" b="0">
+              <a:rPr sz="1300" b="0">
                 <a:solidFill>
                   <a:srgbClr val="FFFFFF"/>
                 </a:solidFill>
@@ -4914,7 +4914,7 @@
               </a:spcAft>
             </a:pPr>
             <a:r>
-              <a:rPr sz="1400" b="0">
+              <a:rPr sz="1300" b="0">
                 <a:solidFill>
                   <a:srgbClr val="FFFFFF"/>
                 </a:solidFill>
@@ -4932,7 +4932,7 @@
               </a:spcAft>
             </a:pPr>
             <a:r>
-              <a:rPr sz="1400" b="0">
+              <a:rPr sz="1300" b="0">
                 <a:solidFill>
                   <a:srgbClr val="FFFFFF"/>
                 </a:solidFill>
@@ -4950,7 +4950,7 @@
               </a:spcAft>
             </a:pPr>
             <a:r>
-              <a:rPr sz="1400" b="0">
+              <a:rPr sz="1300" b="0">
                 <a:solidFill>
                   <a:srgbClr val="FFFFFF"/>
                 </a:solidFill>
@@ -4968,7 +4968,7 @@
               </a:spcAft>
             </a:pPr>
             <a:r>
-              <a:rPr sz="1400" b="0">
+              <a:rPr sz="1300" b="0">
                 <a:solidFill>
                   <a:srgbClr val="FFFFFF"/>
                 </a:solidFill>
@@ -4989,8 +4989,8 @@
         </p:nvSpPr>
         <p:spPr>
           <a:xfrm>
-            <a:off x="6223000" y="1587500"/>
-            <a:ext cx="5461000" cy="1219200"/>
+            <a:off x="6223000" y="1549400"/>
+            <a:ext cx="5461000" cy="1066800"/>
           </a:xfrm>
           <a:prstGeom prst="rect">
             <a:avLst/>
@@ -5035,8 +5035,8 @@
         </p:nvSpPr>
         <p:spPr>
           <a:xfrm>
-            <a:off x="6350000" y="1689100"/>
-            <a:ext cx="5207000" cy="1016000"/>
+            <a:off x="6350000" y="1651000"/>
+            <a:ext cx="5207000" cy="863600"/>
           </a:xfrm>
           <a:prstGeom prst="rect">
             <a:avLst/>
@@ -5055,7 +5055,7 @@
               </a:spcAft>
             </a:pPr>
             <a:r>
-              <a:rPr sz="1500" b="0">
+              <a:rPr sz="1400" b="0">
                 <a:solidFill>
                   <a:srgbClr val="FFFFFF"/>
                 </a:solidFill>
@@ -5073,7 +5073,7 @@
               </a:spcAft>
             </a:pPr>
             <a:r>
-              <a:rPr sz="1500" b="0">
+              <a:rPr sz="1400" b="0">
                 <a:solidFill>
                   <a:srgbClr val="FFFFFF"/>
                 </a:solidFill>
@@ -5091,7 +5091,7 @@
               </a:spcAft>
             </a:pPr>
             <a:r>
-              <a:rPr sz="1500" b="0">
+              <a:rPr sz="1400" b="0">
                 <a:solidFill>
                   <a:srgbClr val="FFFFFF"/>
                 </a:solidFill>
@@ -5112,8 +5112,8 @@
         </p:nvSpPr>
         <p:spPr>
           <a:xfrm>
-            <a:off x="6223000" y="2857500"/>
-            <a:ext cx="5461000" cy="1219200"/>
+            <a:off x="6223000" y="2692400"/>
+            <a:ext cx="5461000" cy="939800"/>
           </a:xfrm>
           <a:prstGeom prst="rect">
             <a:avLst/>
@@ -5158,8 +5158,8 @@
         </p:nvSpPr>
         <p:spPr>
           <a:xfrm>
-            <a:off x="6350000" y="2959100"/>
-            <a:ext cx="5207000" cy="1016000"/>
+            <a:off x="6350000" y="2794000"/>
+            <a:ext cx="5207000" cy="736600"/>
           </a:xfrm>
           <a:prstGeom prst="rect">
             <a:avLst/>
@@ -5178,7 +5178,7 @@
               </a:spcAft>
             </a:pPr>
             <a:r>
-              <a:rPr sz="1500" b="0">
+              <a:rPr sz="1400" b="0">
                 <a:solidFill>
                   <a:srgbClr val="FFFFFF"/>
                 </a:solidFill>
@@ -5196,7 +5196,7 @@
               </a:spcAft>
             </a:pPr>
             <a:r>
-              <a:rPr sz="1500" b="0">
+              <a:rPr sz="1400" b="0">
                 <a:solidFill>
                   <a:srgbClr val="FFFFFF"/>
                 </a:solidFill>
@@ -5211,14 +5211,124 @@
       </p:sp>
       <p:sp>
         <p:nvSpPr>
-          <p:cNvPr id="13" name="Rectangle 12"/>
+          <p:cNvPr id="13" name="TextBox 12"/>
+          <p:cNvSpPr txBox="1"/>
+          <p:nvPr/>
+        </p:nvSpPr>
+        <p:spPr>
+          <a:xfrm>
+            <a:off x="508000" y="3632200"/>
+            <a:ext cx="11176000" cy="203200"/>
+          </a:xfrm>
+          <a:prstGeom prst="rect">
+            <a:avLst/>
+          </a:prstGeom>
+          <a:noFill/>
+        </p:spPr>
+        <p:txBody>
+          <a:bodyPr wrap="square" anchor="t" lIns="50800" rIns="50800" tIns="25400" bIns="25400">
+            <a:spAutoFit/>
+          </a:bodyPr>
+          <a:lstStyle/>
+          <a:p>
+            <a:pPr algn="ctr">
+              <a:spcAft>
+                <a:spcPts val="600"/>
+              </a:spcAft>
+            </a:pPr>
+            <a:r>
+              <a:rPr sz="1200" b="0">
+                <a:solidFill>
+                  <a:srgbClr val="A6A6A6"/>
+                </a:solidFill>
+                <a:latin typeface="Sarabun"/>
+                <a:ea typeface="Sarabun"/>
+                <a:cs typeface="Sarabun"/>
+              </a:rPr>
+              <a:t>ตัวอย่างจริง: เพิ่มนัดเวลาชน → ScheduleConflictError → ข้อความนี้</a:t>
+            </a:r>
+          </a:p>
+        </p:txBody>
+      </p:sp>
+      <p:sp>
+        <p:nvSpPr>
+          <p:cNvPr id="14" name="Rectangle 13"/>
           <p:cNvSpPr/>
           <p:nvPr/>
         </p:nvSpPr>
         <p:spPr>
           <a:xfrm>
-            <a:off x="508000" y="5308600"/>
-            <a:ext cx="11176000" cy="558800"/>
+            <a:off x="2517087" y="3867150"/>
+            <a:ext cx="7157824" cy="1435100"/>
+          </a:xfrm>
+          <a:prstGeom prst="rect">
+            <a:avLst/>
+          </a:prstGeom>
+          <a:solidFill>
+            <a:srgbClr val="444444"/>
+          </a:solidFill>
+          <a:ln>
+            <a:noFill/>
+          </a:ln>
+          <a:effectLst/>
+        </p:spPr>
+        <p:style>
+          <a:lnRef idx="1">
+            <a:schemeClr val="accent1"/>
+          </a:lnRef>
+          <a:fillRef idx="3">
+            <a:schemeClr val="accent1"/>
+          </a:fillRef>
+          <a:effectRef idx="2">
+            <a:schemeClr val="accent1"/>
+          </a:effectRef>
+          <a:fontRef idx="minor">
+            <a:schemeClr val="lt1"/>
+          </a:fontRef>
+        </p:style>
+        <p:txBody>
+          <a:bodyPr rtlCol="0" anchor="ctr"/>
+          <a:lstStyle/>
+          <a:p>
+            <a:pPr algn="ctr"/>
+          </a:p>
+        </p:txBody>
+      </p:sp>
+      <p:pic>
+        <p:nvPicPr>
+          <p:cNvPr id="15" name="Picture 14" descr="schedule_conflict.png"/>
+          <p:cNvPicPr>
+            <a:picLocks noChangeAspect="1"/>
+          </p:cNvPicPr>
+          <p:nvPr/>
+        </p:nvPicPr>
+        <p:blipFill>
+          <a:blip r:embed="rId3"/>
+          <a:srcRect l="12000" t="2000" r="10000" b="80500"/>
+          <a:stretch>
+            <a:fillRect/>
+          </a:stretch>
+        </p:blipFill>
+        <p:spPr>
+          <a:xfrm>
+            <a:off x="2536137" y="3886200"/>
+            <a:ext cx="7119724" cy="1397000"/>
+          </a:xfrm>
+          <a:prstGeom prst="rect">
+            <a:avLst/>
+          </a:prstGeom>
+        </p:spPr>
+      </p:pic>
+      <p:sp>
+        <p:nvSpPr>
+          <p:cNvPr id="16" name="Rectangle 15"/>
+          <p:cNvSpPr/>
+          <p:nvPr/>
+        </p:nvSpPr>
+        <p:spPr>
+          <a:xfrm>
+            <a:off x="508000" y="5384800"/>
+            <a:ext cx="11176000" cy="508000"/>
           </a:xfrm>
           <a:prstGeom prst="rect">
             <a:avLst/>
@@ -5255,14 +5365,14 @@
       </p:sp>
       <p:sp>
         <p:nvSpPr>
-          <p:cNvPr id="14" name="TextBox 13"/>
+          <p:cNvPr id="17" name="TextBox 16"/>
           <p:cNvSpPr txBox="1"/>
           <p:nvPr/>
         </p:nvSpPr>
         <p:spPr>
           <a:xfrm>
-            <a:off x="635000" y="5359400"/>
-            <a:ext cx="10922000" cy="457200"/>
+            <a:off x="635000" y="5435600"/>
+            <a:ext cx="10922000" cy="406400"/>
           </a:xfrm>
           <a:prstGeom prst="rect">
             <a:avLst/>
@@ -5296,7 +5406,7 @@
       </p:sp>
       <p:sp>
         <p:nvSpPr>
-          <p:cNvPr id="15" name="TextBox 14"/>
+          <p:cNvPr id="18" name="TextBox 17"/>
           <p:cNvSpPr txBox="1"/>
           <p:nvPr/>
         </p:nvSpPr>
@@ -15185,8 +15295,8 @@
         </p:nvSpPr>
         <p:spPr>
           <a:xfrm>
-            <a:off x="6900728" y="1784350"/>
-            <a:ext cx="4232542" cy="2832100"/>
+            <a:off x="6330950" y="1915221"/>
+            <a:ext cx="5372100" cy="538357"/>
           </a:xfrm>
           <a:prstGeom prst="rect">
             <a:avLst/>
@@ -15223,7 +15333,7 @@
       </p:sp>
       <p:pic>
         <p:nvPicPr>
-          <p:cNvPr id="14" name="Picture 13" descr="case_detail.png"/>
+          <p:cNvPr id="14" name="Picture 13" descr="case_status_head.png"/>
           <p:cNvPicPr>
             <a:picLocks noChangeAspect="1"/>
           </p:cNvPicPr>
@@ -15231,15 +15341,15 @@
         </p:nvPicPr>
         <p:blipFill>
           <a:blip r:embed="rId3"/>
-          <a:srcRect b="40000"/>
+          <a:srcRect r="40000"/>
           <a:stretch>
             <a:fillRect/>
           </a:stretch>
         </p:blipFill>
         <p:spPr>
           <a:xfrm>
-            <a:off x="6919778" y="1803400"/>
-            <a:ext cx="4194442" cy="2794000"/>
+            <a:off x="6350000" y="1934271"/>
+            <a:ext cx="5334000" cy="500257"/>
           </a:xfrm>
           <a:prstGeom prst="rect">
             <a:avLst/>
@@ -15249,6 +15359,75 @@
       <p:sp>
         <p:nvSpPr>
           <p:cNvPr id="15" name="Rectangle 14"/>
+          <p:cNvSpPr/>
+          <p:nvPr/>
+        </p:nvSpPr>
+        <p:spPr>
+          <a:xfrm>
+            <a:off x="6330950" y="2719189"/>
+            <a:ext cx="5372100" cy="1813321"/>
+          </a:xfrm>
+          <a:prstGeom prst="rect">
+            <a:avLst/>
+          </a:prstGeom>
+          <a:solidFill>
+            <a:srgbClr val="444444"/>
+          </a:solidFill>
+          <a:ln>
+            <a:noFill/>
+          </a:ln>
+          <a:effectLst/>
+        </p:spPr>
+        <p:style>
+          <a:lnRef idx="1">
+            <a:schemeClr val="accent1"/>
+          </a:lnRef>
+          <a:fillRef idx="3">
+            <a:schemeClr val="accent1"/>
+          </a:fillRef>
+          <a:effectRef idx="2">
+            <a:schemeClr val="accent1"/>
+          </a:effectRef>
+          <a:fontRef idx="minor">
+            <a:schemeClr val="lt1"/>
+          </a:fontRef>
+        </p:style>
+        <p:txBody>
+          <a:bodyPr rtlCol="0" anchor="ctr"/>
+          <a:lstStyle/>
+          <a:p>
+            <a:pPr algn="ctr"/>
+          </a:p>
+        </p:txBody>
+      </p:sp>
+      <p:pic>
+        <p:nvPicPr>
+          <p:cNvPr id="16" name="Picture 15" descr="case_status_panel.png"/>
+          <p:cNvPicPr>
+            <a:picLocks noChangeAspect="1"/>
+          </p:cNvPicPr>
+          <p:nvPr/>
+        </p:nvPicPr>
+        <p:blipFill>
+          <a:blip r:embed="rId4"/>
+          <a:srcRect b="70000"/>
+          <a:stretch>
+            <a:fillRect/>
+          </a:stretch>
+        </p:blipFill>
+        <p:spPr>
+          <a:xfrm>
+            <a:off x="6350000" y="2738239"/>
+            <a:ext cx="5334000" cy="1775221"/>
+          </a:xfrm>
+          <a:prstGeom prst="rect">
+            <a:avLst/>
+          </a:prstGeom>
+        </p:spPr>
+      </p:pic>
+      <p:sp>
+        <p:nvSpPr>
+          <p:cNvPr id="17" name="Rectangle 16"/>
           <p:cNvSpPr/>
           <p:nvPr/>
         </p:nvSpPr>
@@ -15292,7 +15471,7 @@
       </p:sp>
       <p:sp>
         <p:nvSpPr>
-          <p:cNvPr id="16" name="TextBox 15"/>
+          <p:cNvPr id="18" name="TextBox 17"/>
           <p:cNvSpPr txBox="1"/>
           <p:nvPr/>
         </p:nvSpPr>
@@ -15333,7 +15512,7 @@
       </p:sp>
       <p:sp>
         <p:nvSpPr>
-          <p:cNvPr id="17" name="TextBox 16"/>
+          <p:cNvPr id="19" name="TextBox 18"/>
           <p:cNvSpPr txBox="1"/>
           <p:nvPr/>
         </p:nvSpPr>

</xml_diff>

<commit_message>
docs(slides): align speaker notes with the simplified slides
Exception notes now follow the slide (error tree in plain Thai, then the
real conflict example) and keep rule codes as a Q&A aside. Encapsulation
notes cover the accept() box. The summary table drops the backup-only
Separation row for Exception and lists only home_url() for polymorphism.

Co-Authored-By: Claude Opus 5.5 <noreply@anthropic.com>
</commit_message>
<xml_diff>
--- a/docs/slides/LawFirm_Presentation.pptx
+++ b/docs/slides/LawFirm_Presentation.pptx
@@ -583,7 +583,7 @@
           <a:lstStyle/>
           <a:p>
             <a:r>
-              <a:t>Polymorphism คือเรียกเมธอดชื่อเดียว แต่ละคลาสตอบไม่เหมือนกัน ตัวอย่างคือ home_url ทนายไปหน้าตารางวันนี้ ผู้จัดการไปหน้า dashboard ของผู้จัดการ แอดมินไปหน้าแอดมิน route เรียกแค่ current_user.home_url() บรรทัดเดียว ไม่ต้องถามว่าเป็น role ไหน หน้าแรกสามแบบในสไลด์ 3 มาจากบรรทัดนี้ครับ ส่วน reminder_lead_days ของนัดสามชนิดก็เรียกบรรทัดเดียวเหมือนกันครับ</a:t>
+              <a:t>Polymorphism คือเรียกเมธอดชื่อเดียว แต่ละคลาสตอบไม่เหมือนกัน ตัวอย่างคือ home_url ทนายไปหน้าตารางวันนี้ ผู้จัดการไปหน้า dashboard ของผู้จัดการ แอดมินไปหน้าแอดมิน route เรียกแค่ current_user.home_url() บรรทัดเดียว ไม่ต้องถามว่าเป็น role ไหน หน้าแรกสามแบบในสไลด์ 3 มาจากบรรทัดนี้ ส่วน reminder_lead_days ของนัดสามชนิดก็ใช้หลักเดียวกันครับ</a:t>
             </a:r>
           </a:p>
         </p:txBody>
@@ -653,7 +653,7 @@
           <a:lstStyle/>
           <a:p>
             <a:r>
-              <a:t>Encapsulation สถานะของคดีกับสถานะการมอบหมายแก้ตรงจากข้างนอกไม่ได้ เก็บไว้ใน _status และเปิดให้อ่านผ่าน property status ที่ไม่มี setter ถ้าสั่ง case.status = ... จะได้ AttributeError การเปลี่ยนสถานะต้องผ่านเมธอดที่ตรวจกฎก่อน เช่น advance_status ต้องเลื่อนทีละขั้น และจะยื่นฟ้องได้ต้องมีทนายตอบรับแล้ว ถ้าผิดกฎจะโยน error ภาพขวาบนคือหัวคดี ป้ายสถานะบอกว่าอยู่ขั้นสืบพยาน ภาพขวาล่างคือแผงจัดการคดี มีปุ่มม่วงปุ่มเดียวคือเลื่อนสถานะเป็นตัดสิน เพราะ advance_status ไม่ยอมให้ข้ามขั้น ข้อยกเว้นมีที่เดียวคือ repository ตั้ง _status ตรงตอนโหลดแถวเดิมจากฐาน ค่านั้นผ่านกฎมาแล้วตอนบันทึก จึงไม่ต้องตรวจซ้ำครับ</a:t>
+              <a:t>Encapsulation สถานะของคดีกับสถานะการมอบหมายแก้ตรงจากข้างนอกไม่ได้ เก็บไว้ใน _status และเปิดให้อ่านผ่าน property status ที่ไม่มี setter ถ้าสั่ง case.status = ... จะได้ AttributeError การเปลี่ยนสถานะต้องผ่านเมธอดที่ตรวจกฎก่อน เช่น advance_status ต้องเลื่อนทีละขั้น และจะยื่นฟ้องได้ต้องมีทนายตอบรับแล้ว ถ้าผิดกฎจะโยน error กล่องล่างคือการมอบหมายใช้หลักเดียวกัน accept ตรวจก่อนว่ายังรอตอบรับอยู่ แล้วจึงเปลี่ยนเป็น ACCEPTED ภาพขวาบนคือหัวคดี ป้ายสถานะบอกว่าอยู่ขั้นสืบพยาน ภาพขวาล่างคือแผงจัดการคดี มีปุ่มม่วงปุ่มเดียวคือเลื่อนสถานะเป็นตัดสิน เพราะ advance_status ไม่ยอมให้ข้ามขั้น ข้อยกเว้นมีที่เดียวคือ repository ตั้ง _status ตรงตอนโหลดแถวเดิมจากฐาน ค่านั้นผ่านกฎมาแล้วตอนบันทึก จึงไม่ต้องตรวจซ้ำครับ</a:t>
             </a:r>
           </a:p>
         </p:txBody>
@@ -723,7 +723,7 @@
           <a:lstStyle/>
           <a:p>
             <a:r>
-              <a:t>Exception hierarchy error ทุกตัวในระบบเป็นคลาส มีแม่คือ DomainError และลูกสี่ตัวตามกลุ่มกฎ นัดชนตาม BR-1 เปลี่ยนสถานะผิดตาม BR-7 8 9 18 เลื่อนนัดไม่ได้ตาม BR-3 กับ 5 และการมอบหมายผิดกฎ BR-15 ถึง 19 ชั้น api ไม่มี handler กลาง แต่ละ route จับ subclass ของตัวเองแล้วแปลเป็นภาษาคน เช่น นัดชนก็แสดงฟอร์มเดิมพร้อมข้อความ หรือมอบหมายผิดก็ตอบ HTTP 409 เทสต้อง assert ชนิด subclass ที่เจาะจงครับ ตัวอย่างจริงอยู่กลางสไลด์ กรอกนัดพบลูกความทับเวลานัดเดิมของทนายคนเดียวกัน ระบบโยน ScheduleConflictError แล้วหน้าเว็บแสดงแถบแดงพร้อมข้อความนี้ ไม่ได้เงียบหายครับ</a:t>
+              <a:t>error ทุกตัวในระบบเป็นคลาส แม่คือ DomainError มีลูกสี่ตัวตามชนิดความผิด คือนัดเวลาชนกัน ข้ามขั้นสถานะ เลื่อนนัดไม่ได้ และมอบหมายหรือรับคดีผิดกฎ ตัวอย่างจริงอยู่กลางสไลด์ ผมกรอกนัดพบลูกความทับเวลานัดเดิมของทนายคนเดียวกัน ระบบโยน ScheduleConflictError แล้ว route ที่จับ error ชนิดนี้ไว้จะแสดงฟอร์มเดิมพร้อมแถบแดง ไม่บันทึกนัดนั้น สรุปคือทำผิดกฎแล้วได้ error ชนิดเฉพาะ และหน้าเว็บแปลเป็นข้อความไทยครับ (ถ้าถูกถาม: รหัสกฎคือ BR-1, BR-7 8 9 18, BR-3 กับ 5 และ BR-15 ถึง 19 ไม่มี handler กลาง แต่ละ route จับ subclass ของตัวเอง และเทส assert ชนิด subclass ที่เจาะจง)</a:t>
             </a:r>
           </a:p>
         </p:txBody>
@@ -863,7 +863,7 @@
           <a:lstStyle/>
           <a:p>
             <a:r>
-              <a:t>สรุป สี่หลักของ OOP ที่โชว์ในระบบนี้ Encapsulation สถานะคดีและการมอบหมายอ่านได้อย่างเดียว เปลี่ยนผ่านเมธอดที่ตรวจกฎ Abstraction Person SystemUser และ Appointment ประกาศสัญญาให้ลูกเติม Inheritance ผู้ใช้สามบทบาทสืบจาก SystemUser และนัดสามชนิดสืบจาก Appointment ซึ่งเป็น is-a จริง Polymorphism home_url กับ reminder_lead_days เรียกบรรทัดเดียวไม่ต้องถามชนิด นอกจากนี้ยังแยกชั้นสถาปัตยกรรมให้พึ่งพาไปทางเดียว ซึ่งตรวจได้ด้วย grep งานต่อยอดคือแจ้งเตือนทางอีเมลหรือไลน์ ซิงก์ปฏิทิน และสิทธิ์ละเอียดต่อคดี กฎทั้งหมดนี้มีเทสคุม 90 เทส ผ่านทั้งหมด กฎธุรกิจทั้งหมดอยู่ในเมธอดของคลาสใน domain ขอบคุณครับ เปิดรับคำถามครับ</a:t>
+              <a:t>สรุป สี่หลักของ OOP ที่โชว์ในระบบนี้ Encapsulation สถานะคดีและการมอบหมายอ่านได้อย่างเดียว เปลี่ยนผ่านเมธอดที่ตรวจกฎ Abstraction Person SystemUser และ Appointment ประกาศสัญญาให้ลูกเติม Inheritance ผู้ใช้สามบทบาทสืบจาก SystemUser และนัดสามชนิดสืบจาก Appointment ซึ่งเป็น is-a จริง Polymorphism home_url บรรทัดเดียวพาผู้ใช้ไปหน้าแรกตามบทบาท และ Exception ทำผิดกฎแล้วได้ error ชนิดเฉพาะที่หน้าเว็บแปลเป็นข้อความไทย งานต่อยอดคือแจ้งเตือนทางอีเมลหรือไลน์ ซิงก์ปฏิทิน และสิทธิ์ละเอียดต่อคดี กฎทั้งหมดนี้มีเทสคุม 90 เทส ผ่านทั้งหมด กฎธุรกิจทั้งหมดอยู่ในเมธอดของคลาสใน domain ขอบคุณครับ เปิดรับคำถามครับ</a:t>
             </a:r>
           </a:p>
         </p:txBody>
@@ -1143,7 +1143,7 @@
           <a:lstStyle/>
           <a:p>
             <a:r>
-              <a:t>ฝั่งคดีและตาราง ตรงกลางคือ Case เก็บสถานะและรายการมอบหมายไว้เป็น private คดีหนึ่งมี CaseAssignment ได้หลายรายการ ซ้ายล่าง Appointment เป็นคลาส abstract มีลูกสามชนิด ขวามือ Schedule ไม่ได้สร้างนัดเอง แค่ยืมรายการนัดจาก repository มาตรวจนัดชน ฉบับเต็มของแผนภาพนี้อยู่ในสไลด์สำรอง B7 ครับ</a:t>
+              <a:t>ฝั่งคดีและตาราง ตรงกลางคือ Case เก็บสถานะและรายการมอบหมายไว้เป็น private คดีหนึ่งมี CaseAssignment ได้หลายรายการ ซ้ายล่าง Appointment เป็นคลาส abstract มีลูกสามชนิด ขวามือ Schedule ไม่ได้สร้างนัดเอง แค่ยืมรายการนัดจาก repository มาตรวจนัดชน ฉบับเต็มที่มีเมธอดครบอยู่ในไฟล์สำรอง หน้า B7 ครับ</a:t>
             </a:r>
           </a:p>
         </p:txBody>
@@ -7247,7 +7247,7 @@
                           <a:ea typeface="Sarabun"/>
                           <a:cs typeface="Sarabun"/>
                         </a:rPr>
-                        <a:t>home_url() / reminder_lead_days() เรียกบรรทัดเดียว ไม่ถามชนิด</a:t>
+                        <a:t>home_url() บรรทัดเดียว ได้หน้าแรก 3 แบบ ไม่ถามชนิด</a:t>
                       </a:r>
                     </a:p>
                   </a:txBody>
@@ -7273,7 +7273,7 @@
                           <a:ea typeface="Sarabun"/>
                           <a:cs typeface="Sarabun"/>
                         </a:rPr>
-                        <a:t>Separation</a:t>
+                        <a:t>Exception</a:t>
                       </a:r>
                     </a:p>
                   </a:txBody>
@@ -7297,7 +7297,7 @@
                           <a:ea typeface="Sarabun"/>
                           <a:cs typeface="Sarabun"/>
                         </a:rPr>
-                        <a:t>api → repository → domain ทิศทางเดียว ตรวจด้วย grep ได้</a:t>
+                        <a:t>ทำผิดกฎ → error ชนิดเฉพาะ → ข้อความไทย</a:t>
                       </a:r>
                     </a:p>
                   </a:txBody>

</xml_diff>

<commit_message>
docs(slides): add closing slide and final pass on speaker notes
Main deck gets a 13th "จบการนำเสนอ" slide that carries the thank-you
line, so the summary notes end on the takeaway. Summary notes now name
the error-handling row, and the backup demo notes read as an
on-request script. speaker_notes.md is re-exported from the decks.

Co-Authored-By: Claude Opus 5.5 <noreply@anthropic.com>
</commit_message>
<xml_diff>
--- a/docs/slides/LawFirm_Presentation.pptx
+++ b/docs/slides/LawFirm_Presentation.pptx
@@ -17,6 +17,7 @@
     <p:sldId id="268" r:id="rId20"/>
     <p:sldId id="269" r:id="rId21"/>
     <p:sldId id="273" r:id="rId25"/>
+    <p:sldId id="276" r:id="rId28"/>
   </p:sldIdLst>
   <p:sldSz cx="12192000" cy="6858000" type="screen4x3"/>
   <p:notesSz cx="6858000" cy="9144000"/>
@@ -863,7 +864,7 @@
           <a:lstStyle/>
           <a:p>
             <a:r>
-              <a:t>สรุป สี่หลักของ OOP ที่โชว์ในระบบนี้ Encapsulation สถานะคดีและการมอบหมายอ่านได้อย่างเดียว เปลี่ยนผ่านเมธอดที่ตรวจกฎ Abstraction Person SystemUser และ Appointment ประกาศสัญญาให้ลูกเติม Inheritance ผู้ใช้สามบทบาทสืบจาก SystemUser และนัดสามชนิดสืบจาก Appointment ซึ่งเป็น is-a จริง Polymorphism home_url บรรทัดเดียวพาผู้ใช้ไปหน้าแรกตามบทบาท และ Exception ทำผิดกฎแล้วได้ error ชนิดเฉพาะที่หน้าเว็บแปลเป็นข้อความไทย งานต่อยอดคือแจ้งเตือนทางอีเมลหรือไลน์ ซิงก์ปฏิทิน และสิทธิ์ละเอียดต่อคดี กฎทั้งหมดนี้มีเทสคุม 90 เทส ผ่านทั้งหมด กฎธุรกิจทั้งหมดอยู่ในเมธอดของคลาสใน domain ขอบคุณครับ เปิดรับคำถามครับ</a:t>
+              <a:t>สรุป สี่หลักของ OOP กับการจัดการ error ที่โชว์ในระบบนี้ Encapsulation สถานะคดีและการมอบหมายอ่านได้อย่างเดียว เปลี่ยนผ่านเมธอดที่ตรวจกฎ Abstraction Person SystemUser และ Appointment ประกาศสัญญาให้ลูกเติม Inheritance ผู้ใช้สามบทบาทสืบจาก SystemUser และนัดสามชนิดสืบจาก Appointment ซึ่งเป็น is-a จริง Polymorphism home_url บรรทัดเดียวพาผู้ใช้ไปหน้าแรกตามบทบาท และ Exception ทำผิดกฎแล้วได้ error ชนิดเฉพาะที่หน้าเว็บแปลเป็นข้อความไทย งานต่อยอดคือแจ้งเตือนทางอีเมลหรือไลน์ ซิงก์ปฏิทิน และสิทธิ์ละเอียดต่อคดี กฎทั้งหมดนี้มีเทสคุม 90 เทส ผ่านทั้งหมด กฎธุรกิจทั้งหมดอยู่ในเมธอดของคลาสใน domain ครับ</a:t>
             </a:r>
           </a:p>
         </p:txBody>
@@ -934,6 +935,76 @@
           <a:p>
             <a:r>
               <a:t>ปัญหาตั้งต้นมาจากสำนักงานกฎหมายที่ยังใช้สมุดกับแชตจัดงาน มีสี่เรื่อง หนึ่ง รับนัดใหม่โดยไม่รู้ว่าวันนั้นมีนัดคดีอื่นอยู่แล้ว สอง กำหนดยื่นตามกฎหมาย เช่น คำให้การ อุทธรณ์ ฎีกา ไม่มีอะไรนับวันให้ สาม มอบหมายงานทางแชต ไม่รู้ว่าทนายเห็นหรือรับงานแล้วหรือยัง และสี่ แจกคดีใหม่โดยไม่เห็นว่าใครงานแน่นแค่ไหน ระบบจึงมีผู้ใช้สามบทบาท ทนายดูนัดวันนี้และตอบรับคดี ผู้จัดการมอบหมายคดีตามภาระงาน และแอดมินจัดการบัญชี โดยแอดมินไม่เห็นเนื้อหาคดีเลยครับ</a:t>
+            </a:r>
+          </a:p>
+        </p:txBody>
+      </p:sp>
+      <p:sp>
+        <p:nvSpPr>
+          <p:cNvPr id="4" name="Slide Number Placeholder 3"/>
+          <p:cNvSpPr>
+            <a:spLocks noGrp="1"/>
+          </p:cNvSpPr>
+          <p:nvPr>
+            <p:ph type="sldNum" idx="5" sz="quarter"/>
+          </p:nvPr>
+        </p:nvSpPr>
+        <p:spPr/>
+      </p:sp>
+    </p:spTree>
+  </p:cSld>
+  <p:clrMapOvr>
+    <a:masterClrMapping/>
+  </p:clrMapOvr>
+</p:notes>
+</file>
+
+<file path=ppt/notesSlides/notesSlide21.xml><?xml version="1.0" encoding="utf-8"?>
+<p:notes xmlns:a="http://schemas.openxmlformats.org/drawingml/2006/main" xmlns:p="http://schemas.openxmlformats.org/presentationml/2006/main" xmlns:r="http://schemas.openxmlformats.org/officeDocument/2006/relationships">
+  <p:cSld>
+    <p:spTree>
+      <p:nvGrpSpPr>
+        <p:cNvPr id="1" name=""/>
+        <p:cNvGrpSpPr/>
+        <p:nvPr/>
+      </p:nvGrpSpPr>
+      <p:grpSpPr>
+        <a:xfrm>
+          <a:off x="0" y="0"/>
+          <a:ext cx="0" cy="0"/>
+          <a:chOff x="0" y="0"/>
+          <a:chExt cx="0" cy="0"/>
+        </a:xfrm>
+      </p:grpSpPr>
+      <p:sp>
+        <p:nvSpPr>
+          <p:cNvPr id="2" name="Slide Image Placeholder 1"/>
+          <p:cNvSpPr>
+            <a:spLocks noGrp="1"/>
+          </p:cNvSpPr>
+          <p:nvPr>
+            <p:ph type="sldImg" idx="2"/>
+          </p:nvPr>
+        </p:nvSpPr>
+        <p:spPr/>
+      </p:sp>
+      <p:sp>
+        <p:nvSpPr>
+          <p:cNvPr id="3" name="Notes Placeholder 2"/>
+          <p:cNvSpPr>
+            <a:spLocks noGrp="1"/>
+          </p:cNvSpPr>
+          <p:nvPr>
+            <p:ph type="body" idx="3" sz="quarter"/>
+          </p:nvPr>
+        </p:nvSpPr>
+        <p:spPr/>
+        <p:txBody>
+          <a:bodyPr/>
+          <a:lstStyle/>
+          <a:p>
+            <a:r>
+              <a:t>ขอบคุณครับ เปิดรับคำถามครับ</a:t>
             </a:r>
           </a:p>
         </p:txBody>
@@ -7475,6 +7546,196 @@
                 <a:cs typeface="Sarabun"/>
               </a:rPr>
               <a:t>กฎธุรกิจทั้งหมดอยู่ในเมธอดของคลาสใน domain/</a:t>
+            </a:r>
+          </a:p>
+        </p:txBody>
+      </p:sp>
+    </p:spTree>
+  </p:cSld>
+  <p:clrMapOvr>
+    <a:masterClrMapping/>
+  </p:clrMapOvr>
+</p:sld>
+</file>
+
+<file path=ppt/slides/slide13.xml><?xml version="1.0" encoding="utf-8"?>
+<p:sld xmlns:a="http://schemas.openxmlformats.org/drawingml/2006/main" xmlns:p="http://schemas.openxmlformats.org/presentationml/2006/main" xmlns:r="http://schemas.openxmlformats.org/officeDocument/2006/relationships">
+  <p:cSld>
+    <p:bg>
+      <p:bgPr>
+        <a:solidFill>
+          <a:srgbClr val="1E1E1E"/>
+        </a:solidFill>
+        <a:effectLst/>
+      </p:bgPr>
+    </p:bg>
+    <p:spTree>
+      <p:nvGrpSpPr>
+        <p:cNvPr id="1" name=""/>
+        <p:cNvGrpSpPr/>
+        <p:nvPr/>
+      </p:nvGrpSpPr>
+      <p:grpSpPr/>
+      <p:sp>
+        <p:nvSpPr>
+          <p:cNvPr id="2" name="TextBox 1"/>
+          <p:cNvSpPr txBox="1"/>
+          <p:nvPr/>
+        </p:nvSpPr>
+        <p:spPr>
+          <a:xfrm>
+            <a:off x="10922000" y="355600"/>
+            <a:ext cx="762000" cy="381000"/>
+          </a:xfrm>
+          <a:prstGeom prst="rect">
+            <a:avLst/>
+          </a:prstGeom>
+          <a:noFill/>
+        </p:spPr>
+        <p:txBody>
+          <a:bodyPr wrap="square" anchor="t" lIns="50800" rIns="50800" tIns="25400" bIns="25400">
+            <a:spAutoFit/>
+          </a:bodyPr>
+          <a:lstStyle/>
+          <a:p>
+            <a:pPr algn="r">
+              <a:spcAft>
+                <a:spcPts val="600"/>
+              </a:spcAft>
+            </a:pPr>
+            <a:r>
+              <a:rPr sz="1400" b="0">
+                <a:solidFill>
+                  <a:srgbClr val="A6A6A6"/>
+                </a:solidFill>
+                <a:latin typeface="Sarabun"/>
+                <a:ea typeface="Sarabun"/>
+                <a:cs typeface="Sarabun"/>
+              </a:rPr>
+              <a:t/>
+            </a:r>
+          </a:p>
+        </p:txBody>
+      </p:sp>
+      <p:sp>
+        <p:nvSpPr>
+          <p:cNvPr id="3" name="TextBox 2"/>
+          <p:cNvSpPr txBox="1"/>
+          <p:nvPr/>
+        </p:nvSpPr>
+        <p:spPr>
+          <a:xfrm>
+            <a:off x="508000" y="1905000"/>
+            <a:ext cx="11176000" cy="1016000"/>
+          </a:xfrm>
+          <a:prstGeom prst="rect">
+            <a:avLst/>
+          </a:prstGeom>
+          <a:noFill/>
+        </p:spPr>
+        <p:txBody>
+          <a:bodyPr wrap="square" anchor="t" lIns="50800" rIns="50800" tIns="25400" bIns="25400">
+            <a:spAutoFit/>
+          </a:bodyPr>
+          <a:lstStyle/>
+          <a:p>
+            <a:pPr algn="ctr">
+              <a:spcAft>
+                <a:spcPts val="600"/>
+              </a:spcAft>
+            </a:pPr>
+            <a:r>
+              <a:rPr sz="5400" b="1">
+                <a:solidFill>
+                  <a:srgbClr val="FFFFFF"/>
+                </a:solidFill>
+                <a:latin typeface="Sarabun"/>
+                <a:ea typeface="Sarabun"/>
+                <a:cs typeface="Sarabun"/>
+              </a:rPr>
+              <a:t>จบการนำเสนอ</a:t>
+            </a:r>
+          </a:p>
+        </p:txBody>
+      </p:sp>
+      <p:sp>
+        <p:nvSpPr>
+          <p:cNvPr id="4" name="TextBox 3"/>
+          <p:cNvSpPr txBox="1"/>
+          <p:nvPr/>
+        </p:nvSpPr>
+        <p:spPr>
+          <a:xfrm>
+            <a:off x="508000" y="3175000"/>
+            <a:ext cx="11176000" cy="635000"/>
+          </a:xfrm>
+          <a:prstGeom prst="rect">
+            <a:avLst/>
+          </a:prstGeom>
+          <a:noFill/>
+        </p:spPr>
+        <p:txBody>
+          <a:bodyPr wrap="square" anchor="t" lIns="50800" rIns="50800" tIns="25400" bIns="25400">
+            <a:spAutoFit/>
+          </a:bodyPr>
+          <a:lstStyle/>
+          <a:p>
+            <a:pPr algn="ctr">
+              <a:spcAft>
+                <a:spcPts val="600"/>
+              </a:spcAft>
+            </a:pPr>
+            <a:r>
+              <a:rPr sz="3000" b="0">
+                <a:solidFill>
+                  <a:srgbClr val="A6A6A6"/>
+                </a:solidFill>
+                <a:latin typeface="Sarabun"/>
+                <a:ea typeface="Sarabun"/>
+                <a:cs typeface="Sarabun"/>
+              </a:rPr>
+              <a:t>ขอบคุณครับ</a:t>
+            </a:r>
+          </a:p>
+        </p:txBody>
+      </p:sp>
+      <p:sp>
+        <p:nvSpPr>
+          <p:cNvPr id="5" name="TextBox 4"/>
+          <p:cNvSpPr txBox="1"/>
+          <p:nvPr/>
+        </p:nvSpPr>
+        <p:spPr>
+          <a:xfrm>
+            <a:off x="508000" y="4064000"/>
+            <a:ext cx="11176000" cy="508000"/>
+          </a:xfrm>
+          <a:prstGeom prst="rect">
+            <a:avLst/>
+          </a:prstGeom>
+          <a:noFill/>
+        </p:spPr>
+        <p:txBody>
+          <a:bodyPr wrap="square" anchor="t" lIns="50800" rIns="50800" tIns="25400" bIns="25400">
+            <a:spAutoFit/>
+          </a:bodyPr>
+          <a:lstStyle/>
+          <a:p>
+            <a:pPr algn="ctr">
+              <a:spcAft>
+                <a:spcPts val="600"/>
+              </a:spcAft>
+            </a:pPr>
+            <a:r>
+              <a:rPr sz="2000" b="0">
+                <a:solidFill>
+                  <a:srgbClr val="FFFFFF"/>
+                </a:solidFill>
+                <a:latin typeface="Sarabun"/>
+                <a:ea typeface="Sarabun"/>
+                <a:cs typeface="Sarabun"/>
+              </a:rPr>
+              <a:t>นายเมทนี พูลสมบัติ · รหัสนักศึกษา 6821500060</a:t>
             </a:r>
           </a:p>
         </p:txBody>

</xml_diff>